<commit_message>
docs(track2): add Radeon Cloud bonus path to submission deck
</commit_message>
<xml_diff>
--- a/submissions/track2-radeonstay/docs/RadeonHotel-Track2-Submission.pptx
+++ b/submissions/track2-radeonstay/docs/RadeonHotel-Track2-Submission.pptx
@@ -2,21 +2,22 @@
 <file path=ppt/presentation.xml><?xml version="1.0" encoding="utf-8"?>
 <p:presentation xmlns:p="http://schemas.openxmlformats.org/presentationml/2006/main">
   <p:sldMasterIdLst>
-    <p:sldMasterId xmlns:r="http://schemas.openxmlformats.org/officeDocument/2006/relationships" id="2147483648" r:id="R820d3e862dd5404a"/>
+    <p:sldMasterId xmlns:r="http://schemas.openxmlformats.org/officeDocument/2006/relationships" id="2147483648" r:id="R03b2ba5c97694739"/>
   </p:sldMasterIdLst>
   <p:notesMasterIdLst>
-    <p:notesMasterId xmlns:r="http://schemas.openxmlformats.org/officeDocument/2006/relationships" r:id="R2d616da13bee4498"/>
+    <p:notesMasterId xmlns:r="http://schemas.openxmlformats.org/officeDocument/2006/relationships" r:id="R557301670f894825"/>
   </p:notesMasterIdLst>
   <p:sldIdLst>
-    <p:sldId xmlns:r="http://schemas.openxmlformats.org/officeDocument/2006/relationships" id="256" r:id="R7e4802f5fe144bb1"/>
-    <p:sldId xmlns:r="http://schemas.openxmlformats.org/officeDocument/2006/relationships" id="257" r:id="R9a3b5ac9c03249d1"/>
-    <p:sldId xmlns:r="http://schemas.openxmlformats.org/officeDocument/2006/relationships" id="258" r:id="R433b65c8e07a49b1"/>
-    <p:sldId xmlns:r="http://schemas.openxmlformats.org/officeDocument/2006/relationships" id="259" r:id="R2213a90be08b48e6"/>
-    <p:sldId xmlns:r="http://schemas.openxmlformats.org/officeDocument/2006/relationships" id="260" r:id="R34cc7e5220fa4116"/>
-    <p:sldId xmlns:r="http://schemas.openxmlformats.org/officeDocument/2006/relationships" id="261" r:id="R8d0d7e8bc1324d7d"/>
-    <p:sldId xmlns:r="http://schemas.openxmlformats.org/officeDocument/2006/relationships" id="262" r:id="R3d6dd5889a8b43da"/>
-    <p:sldId xmlns:r="http://schemas.openxmlformats.org/officeDocument/2006/relationships" id="263" r:id="Rc7140f77fc04464d"/>
-    <p:sldId xmlns:r="http://schemas.openxmlformats.org/officeDocument/2006/relationships" id="264" r:id="R4e9fee409d344a06"/>
+    <p:sldId xmlns:r="http://schemas.openxmlformats.org/officeDocument/2006/relationships" id="256" r:id="R60bc23cdeaf44768"/>
+    <p:sldId xmlns:r="http://schemas.openxmlformats.org/officeDocument/2006/relationships" id="257" r:id="R3f125d70b50a4103"/>
+    <p:sldId xmlns:r="http://schemas.openxmlformats.org/officeDocument/2006/relationships" id="258" r:id="Rd390295453c94ab6"/>
+    <p:sldId xmlns:r="http://schemas.openxmlformats.org/officeDocument/2006/relationships" id="259" r:id="Rcb31eeaf5b7341af"/>
+    <p:sldId xmlns:r="http://schemas.openxmlformats.org/officeDocument/2006/relationships" id="260" r:id="R89314ff2e22c4f34"/>
+    <p:sldId xmlns:r="http://schemas.openxmlformats.org/officeDocument/2006/relationships" id="261" r:id="R3828968c4be643da"/>
+    <p:sldId xmlns:r="http://schemas.openxmlformats.org/officeDocument/2006/relationships" id="262" r:id="Reb079fcde2ae4600"/>
+    <p:sldId xmlns:r="http://schemas.openxmlformats.org/officeDocument/2006/relationships" id="263" r:id="Rf27025eceb8d4724"/>
+    <p:sldId xmlns:r="http://schemas.openxmlformats.org/officeDocument/2006/relationships" id="264" r:id="R1f5fae9c72bf4f8c"/>
+    <p:sldId xmlns:r="http://schemas.openxmlformats.org/officeDocument/2006/relationships" id="265" r:id="Rf430ab9e684d4a25"/>
   </p:sldIdLst>
   <p:sldSz cx="12192000" cy="6858000"/>
   <p:notesSz cx="6858000" cy="9144000"/>
@@ -500,6 +501,106 @@
 </p:notes>
 </file>
 
+<file path=ppt/notesSlides/notesSlide10.xml><?xml version="1.0" encoding="utf-8"?>
+<p:notes xmlns:p="http://schemas.openxmlformats.org/presentationml/2006/main">
+  <p:cSld>
+    <p:spTree>
+      <p:nvGrpSpPr>
+        <p:cNvPr id="1" name=""/>
+        <p:cNvGrpSpPr/>
+        <p:nvPr/>
+      </p:nvGrpSpPr>
+      <p:grpSpPr>
+        <a:xfrm xmlns:a="http://schemas.openxmlformats.org/drawingml/2006/main"/>
+      </p:grpSpPr>
+      <p:sp>
+        <p:nvSpPr>
+          <p:cNvPr id="2" name="Slide Image Placeholder 1"/>
+          <p:cNvSpPr>
+            <a:spLocks xmlns:a="http://schemas.openxmlformats.org/drawingml/2006/main" noGrp="1"/>
+          </p:cNvSpPr>
+          <p:nvPr>
+            <p:ph type="sldImg" idx="0"/>
+          </p:nvPr>
+        </p:nvSpPr>
+        <p:spPr/>
+      </p:sp>
+      <p:sp>
+        <p:nvSpPr>
+          <p:cNvPr id="3" name="Notes Placeholder 2"/>
+          <p:cNvSpPr>
+            <a:spLocks xmlns:a="http://schemas.openxmlformats.org/drawingml/2006/main" noGrp="1"/>
+          </p:cNvSpPr>
+          <p:nvPr>
+            <p:ph type="body" idx="1"/>
+          </p:nvPr>
+        </p:nvSpPr>
+        <p:spPr/>
+        <p:txBody>
+          <a:bodyPr xmlns:a="http://schemas.openxmlformats.org/drawingml/2006/main"/>
+          <a:lstStyle xmlns:a="http://schemas.openxmlformats.org/drawingml/2006/main"/>
+          <a:p xmlns:a="http://schemas.openxmlformats.org/drawingml/2006/main">
+            <a:r>
+              <a:t>Close by returning to verifiability. Invite judges to open the live demo, follow the unique CTA, and inspect Advanced Proof. The optional Cloud API route is implemented but is not represented as accepted bonus evidence.</a:t>
+            </a:r>
+          </a:p>
+          <a:p xmlns:a="http://schemas.openxmlformats.org/drawingml/2006/main">
+            <a:r>
+              <a:t/>
+            </a:r>
+          </a:p>
+          <a:p xmlns:a="http://schemas.openxmlformats.org/drawingml/2006/main">
+            <a:r>
+              <a:t>[Sources]</a:t>
+            </a:r>
+          </a:p>
+          <a:p xmlns:a="http://schemas.openxmlformats.org/drawingml/2006/main">
+            <a:r>
+              <a:t>- README.md</a:t>
+            </a:r>
+          </a:p>
+          <a:p xmlns:a="http://schemas.openxmlformats.org/drawingml/2006/main">
+            <a:r>
+              <a:t>- docs/evidence-index.md</a:t>
+            </a:r>
+          </a:p>
+          <a:p xmlns:a="http://schemas.openxmlformats.org/drawingml/2006/main">
+            <a:r>
+              <a:t>- https://github.com/AMD-DEV-CONTEST/Radeon-hackathon-2026-07/pull/192</a:t>
+            </a:r>
+          </a:p>
+          <a:p xmlns:a="http://schemas.openxmlformats.org/drawingml/2006/main">
+            <a:r>
+              <a:t>- https://rc-5ec89b08f896792e.radeon.firstdg.ai/</a:t>
+            </a:r>
+          </a:p>
+        </p:txBody>
+      </p:sp>
+      <p:sp>
+        <p:nvSpPr>
+          <p:cNvPr id="4" name="Slide Number Placeholder 3"/>
+          <p:cNvSpPr>
+            <a:spLocks xmlns:a="http://schemas.openxmlformats.org/drawingml/2006/main" noGrp="1"/>
+          </p:cNvSpPr>
+          <p:nvPr>
+            <p:ph type="sldNum" idx="5"/>
+          </p:nvPr>
+        </p:nvSpPr>
+        <p:spPr/>
+        <p:txBody>
+          <a:bodyPr xmlns:a="http://schemas.openxmlformats.org/drawingml/2006/main"/>
+          <a:lstStyle xmlns:a="http://schemas.openxmlformats.org/drawingml/2006/main"/>
+          <a:p xmlns:a="http://schemas.openxmlformats.org/drawingml/2006/main"/>
+        </p:txBody>
+      </p:sp>
+    </p:spTree>
+  </p:cSld>
+  <p:clrMapOvr>
+    <a:masterClrMapping xmlns:a="http://schemas.openxmlformats.org/drawingml/2006/main"/>
+  </p:clrMapOvr>
+</p:notes>
+</file>
+
 <file path=ppt/notesSlides/notesSlide2.xml><?xml version="1.0" encoding="utf-8"?>
 <p:notes xmlns:p="http://schemas.openxmlformats.org/presentationml/2006/main">
   <p:cSld>
@@ -630,7 +731,7 @@
           <a:lstStyle xmlns:a="http://schemas.openxmlformats.org/drawingml/2006/main"/>
           <a:p xmlns:a="http://schemas.openxmlformats.org/drawingml/2006/main">
             <a:r>
-              <a:t>Walk left to right. Emphasize that the local LLM is powerful but never authoritative over hotel state.</a:t>
+              <a:t>Walk left to right. Emphasize that the local LLM is powerful but never authoritative over hotel state, and that the base-100 path is independent of the optional Cloud API route.</a:t>
             </a:r>
           </a:p>
           <a:p xmlns:a="http://schemas.openxmlformats.org/drawingml/2006/main">
@@ -651,6 +752,11 @@
           <a:p xmlns:a="http://schemas.openxmlformats.org/drawingml/2006/main">
             <a:r>
               <a:t>- docs/project-specification.md — Agent architecture</a:t>
+            </a:r>
+          </a:p>
+          <a:p xmlns:a="http://schemas.openxmlformats.org/drawingml/2006/main">
+            <a:r>
+              <a:t>- src/radeonstay/main.py — Local and optional-cloud routing boundary</a:t>
             </a:r>
           </a:p>
         </p:txBody>
@@ -1175,7 +1281,7 @@
           <a:lstStyle xmlns:a="http://schemas.openxmlformats.org/drawingml/2006/main"/>
           <a:p xmlns:a="http://schemas.openxmlformats.org/drawingml/2006/main">
             <a:r>
-              <a:t>Close by returning to verifiability. Invite judges to open the live demo, follow the unique CTA, and inspect Advanced Proof.</a:t>
+              <a:t>Present this as an optional, explicitly isolated bonus route. Do not claim a validated bonus score, accepted performance comparison, or verified server-side quantization.</a:t>
             </a:r>
           </a:p>
           <a:p xmlns:a="http://schemas.openxmlformats.org/drawingml/2006/main">
@@ -1190,17 +1296,37 @@
           </a:p>
           <a:p xmlns:a="http://schemas.openxmlformats.org/drawingml/2006/main">
             <a:r>
-              <a:t>- README.md</a:t>
-            </a:r>
-          </a:p>
-          <a:p xmlns:a="http://schemas.openxmlformats.org/drawingml/2006/main">
-            <a:r>
-              <a:t>- docs/evidence-index.md</a:t>
-            </a:r>
-          </a:p>
-          <a:p xmlns:a="http://schemas.openxmlformats.org/drawingml/2006/main">
-            <a:r>
-              <a:t>- https://rc-5ec89b08f896792e.radeon.firstdg.ai/</a:t>
+              <a:t>- https://github.com/AMD-DEV-CONTEST/Radeon-hackathon-2026-07/tree/main/Radeon-Cloud-User%20Guide — Official Radeon Cloud user guide</a:t>
+            </a:r>
+          </a:p>
+          <a:p xmlns:a="http://schemas.openxmlformats.org/drawingml/2006/main">
+            <a:r>
+              <a:t>- .env.example — Explicit opt-in configuration</a:t>
+            </a:r>
+          </a:p>
+          <a:p xmlns:a="http://schemas.openxmlformats.org/drawingml/2006/main">
+            <a:r>
+              <a:t>- src/radeonstay/config.py — Backend and allow-list configuration</a:t>
+            </a:r>
+          </a:p>
+          <a:p xmlns:a="http://schemas.openxmlformats.org/drawingml/2006/main">
+            <a:r>
+              <a:t>- src/radeonstay/main.py — Runtime isolation and proof boundary</a:t>
+            </a:r>
+          </a:p>
+          <a:p xmlns:a="http://schemas.openxmlformats.org/drawingml/2006/main">
+            <a:r>
+              <a:t>- src/radeonstay/cloud_model_client.py — Radeon Cloud Public Free API client</a:t>
+            </a:r>
+          </a:p>
+          <a:p xmlns:a="http://schemas.openxmlformats.org/drawingml/2006/main">
+            <a:r>
+              <a:t>- src/radeonstay/planning.py — Fused planning and evidence-selection mode</a:t>
+            </a:r>
+          </a:p>
+          <a:p xmlns:a="http://schemas.openxmlformats.org/drawingml/2006/main">
+            <a:r>
+              <a:t>- No bonus score, accepted benchmark, or server-side quantization result is claimed on this slide.</a:t>
             </a:r>
           </a:p>
         </p:txBody>
@@ -1268,7 +1394,7 @@
   </p:cSld>
   <p:clrMap bg1="lt1" tx1="dk1" bg2="lt2" tx2="dk2" accent1="accent1" accent2="accent2" accent3="accent3" accent4="accent4" accent5="accent5" accent6="accent6" hlink="hlink" folHlink="folHlink"/>
   <p:sldLayoutIdLst>
-    <p:sldLayoutId xmlns:r="http://schemas.openxmlformats.org/officeDocument/2006/relationships" id="2147483649" r:id="Re75d67e0e0d24396"/>
+    <p:sldLayoutId xmlns:r="http://schemas.openxmlformats.org/officeDocument/2006/relationships" id="2147483649" r:id="Rad176ceea46b497f"/>
   </p:sldLayoutIdLst>
   <p:txStyles>
     <p:titleStyle>
@@ -2108,6 +2234,7 @@
           <a:lstStyle xmlns:a="http://schemas.openxmlformats.org/drawingml/2006/main"/>
           <a:p xmlns:a="http://schemas.openxmlformats.org/drawingml/2006/main">
             <a:pPr algn="l">
+              <a:buNone/>
               <a:defRPr sz="1275" b="1">
                 <a:solidFill>
                   <a:srgbClr val="3D8DFF"/>
@@ -2164,6 +2291,7 @@
           <a:lstStyle xmlns:a="http://schemas.openxmlformats.org/drawingml/2006/main"/>
           <a:p xmlns:a="http://schemas.openxmlformats.org/drawingml/2006/main">
             <a:pPr algn="l">
+              <a:buNone/>
               <a:defRPr sz="4800" b="1">
                 <a:solidFill>
                   <a:srgbClr val="000000"/>
@@ -2220,6 +2348,7 @@
           <a:lstStyle xmlns:a="http://schemas.openxmlformats.org/drawingml/2006/main"/>
           <a:p xmlns:a="http://schemas.openxmlformats.org/drawingml/2006/main">
             <a:pPr algn="l">
+              <a:buNone/>
               <a:defRPr sz="2325" b="1">
                 <a:solidFill>
                   <a:srgbClr val="000000"/>
@@ -2276,6 +2405,7 @@
           <a:lstStyle xmlns:a="http://schemas.openxmlformats.org/drawingml/2006/main"/>
           <a:p xmlns:a="http://schemas.openxmlformats.org/drawingml/2006/main">
             <a:pPr algn="l">
+              <a:buNone/>
               <a:defRPr sz="1725" b="0">
                 <a:solidFill>
                   <a:srgbClr val="5F6368"/>
@@ -2332,6 +2462,7 @@
           <a:lstStyle xmlns:a="http://schemas.openxmlformats.org/drawingml/2006/main"/>
           <a:p xmlns:a="http://schemas.openxmlformats.org/drawingml/2006/main">
             <a:pPr algn="l">
+              <a:buNone/>
               <a:defRPr sz="1350" b="0">
                 <a:solidFill>
                   <a:srgbClr val="5F6368"/>
@@ -2392,14 +2523,14 @@
       </p:sp>
       <p:pic>
         <p:nvPicPr>
-          <p:cNvPr id="14" name=""/>
+          <p:cNvPr id="16" name=""/>
           <p:cNvPicPr>
             <a:picLocks xmlns:a="http://schemas.openxmlformats.org/drawingml/2006/main" noChangeAspect="1"/>
           </p:cNvPicPr>
           <p:nvPr/>
         </p:nvPicPr>
         <p:blipFill>
-          <a:blip xmlns:r="http://schemas.openxmlformats.org/officeDocument/2006/relationships" xmlns:a="http://schemas.openxmlformats.org/drawingml/2006/main" r:embed="Ra70f38c6f5f64fc3"/>
+          <a:blip xmlns:r="http://schemas.openxmlformats.org/officeDocument/2006/relationships" xmlns:a="http://schemas.openxmlformats.org/drawingml/2006/main" r:embed="Rde884aaecc6f4363"/>
           <a:srcRect xmlns:a="http://schemas.openxmlformats.org/drawingml/2006/main" l="595" t="0" r="595" b="0"/>
           <a:stretch xmlns:a="http://schemas.openxmlformats.org/drawingml/2006/main">
             <a:fillRect l="0" t="0" r="0" b="0"/>
@@ -2421,6 +2552,467 @@
     <p:extLst>
       <p:ext uri="{BB962C8B-B14F-4D97-AF65-F5344CB8AC3E}">
         <p14:creationId xmlns:p14="http://schemas.microsoft.com/office/powerpoint/2010/main" val="544444288"/>
+      </p:ext>
+    </p:extLst>
+  </p:cSld>
+</p:sld>
+</file>
+
+<file path=ppt/slides/slide10.xml><?xml version="1.0" encoding="utf-8"?>
+<p:sld xmlns:p="http://schemas.openxmlformats.org/presentationml/2006/main">
+  <p:cSld>
+    <p:bg>
+      <p:bgPr>
+        <a:solidFill xmlns:a="http://schemas.openxmlformats.org/drawingml/2006/main">
+          <a:srgbClr val="FFFFFF"/>
+        </a:solidFill>
+      </p:bgPr>
+    </p:bg>
+    <p:spTree>
+      <p:nvGrpSpPr>
+        <p:cNvPr id="1" name=""/>
+        <p:cNvGrpSpPr/>
+        <p:nvPr/>
+      </p:nvGrpSpPr>
+      <p:grpSpPr>
+        <a:xfrm xmlns:a="http://schemas.openxmlformats.org/drawingml/2006/main"/>
+      </p:grpSpPr>
+      <p:sp>
+        <p:nvSpPr>
+          <p:cNvPr id="9" name="">
+            <a:extLst xmlns:a="http://schemas.openxmlformats.org/drawingml/2006/main">
+              <a:ext uri="{FF2B5EF4-FFF2-40B4-BE49-F238E27FC236}">
+                <a16:creationId xmlns:a16="http://schemas.microsoft.com/office/drawing/2014/main" id="{34AE98F7-7BF8-42CA-AD69-6BBE6B317081}"/>
+              </a:ext>
+            </a:extLst>
+          </p:cNvPr>
+          <p:cNvSpPr>
+            <a:spLocks xmlns:a="http://schemas.openxmlformats.org/drawingml/2006/main" noGrp="1"/>
+          </p:cNvSpPr>
+          <p:nvPr/>
+        </p:nvSpPr>
+        <p:spPr>
+          <a:xfrm xmlns:a="http://schemas.openxmlformats.org/drawingml/2006/main">
+            <a:off x="400050" y="400050"/>
+            <a:ext cx="3429000" cy="323850"/>
+          </a:xfrm>
+          <a:prstGeom xmlns:a="http://schemas.openxmlformats.org/drawingml/2006/main" prst="rect">
+            <a:avLst/>
+          </a:prstGeom>
+          <a:noFill xmlns:a="http://schemas.openxmlformats.org/drawingml/2006/main"/>
+          <a:ln xmlns:a="http://schemas.openxmlformats.org/drawingml/2006/main" w="0">
+            <a:noFill/>
+            <a:prstDash val="solid"/>
+          </a:ln>
+        </p:spPr>
+        <p:txBody>
+          <a:bodyPr xmlns:a="http://schemas.openxmlformats.org/drawingml/2006/main" anchor="t"/>
+          <a:lstStyle xmlns:a="http://schemas.openxmlformats.org/drawingml/2006/main"/>
+          <a:p xmlns:a="http://schemas.openxmlformats.org/drawingml/2006/main">
+            <a:pPr algn="l">
+              <a:buNone/>
+              <a:defRPr sz="1350" b="1">
+                <a:solidFill>
+                  <a:srgbClr val="3D8DFF"/>
+                </a:solidFill>
+                <a:latin typeface="Helvetica Neue"/>
+                <a:ea typeface="Helvetica Neue"/>
+                <a:cs typeface="Helvetica Neue"/>
+              </a:defRPr>
+            </a:pPr>
+            <a:r>
+              <a:rPr sz="1350" b="1">
+                <a:solidFill>
+                  <a:srgbClr val="3D8DFF"/>
+                </a:solidFill>
+                <a:latin typeface="Helvetica Neue"/>
+                <a:ea typeface="Helvetica Neue"/>
+                <a:cs typeface="Helvetica Neue"/>
+              </a:rPr>
+              <a:t>TRACK 2 · RADEONHOTEL</a:t>
+            </a:r>
+          </a:p>
+        </p:txBody>
+      </p:sp>
+      <p:sp>
+        <p:nvSpPr>
+          <p:cNvPr id="2" name="">
+            <a:extLst xmlns:a="http://schemas.openxmlformats.org/drawingml/2006/main">
+              <a:ext uri="{FF2B5EF4-FFF2-40B4-BE49-F238E27FC236}">
+                <a16:creationId xmlns:a16="http://schemas.microsoft.com/office/drawing/2014/main" id="{577713F9-EDC5-4976-904C-CF0CE4F86238}"/>
+              </a:ext>
+            </a:extLst>
+          </p:cNvPr>
+          <p:cNvSpPr>
+            <a:spLocks xmlns:a="http://schemas.openxmlformats.org/drawingml/2006/main" noGrp="1"/>
+          </p:cNvSpPr>
+          <p:nvPr/>
+        </p:nvSpPr>
+        <p:spPr>
+          <a:xfrm xmlns:a="http://schemas.openxmlformats.org/drawingml/2006/main">
+            <a:off x="400050" y="1638300"/>
+            <a:ext cx="9620250" cy="2000250"/>
+          </a:xfrm>
+          <a:prstGeom xmlns:a="http://schemas.openxmlformats.org/drawingml/2006/main" prst="rect">
+            <a:avLst/>
+          </a:prstGeom>
+          <a:noFill xmlns:a="http://schemas.openxmlformats.org/drawingml/2006/main"/>
+          <a:ln xmlns:a="http://schemas.openxmlformats.org/drawingml/2006/main" w="0">
+            <a:noFill/>
+            <a:prstDash val="solid"/>
+          </a:ln>
+        </p:spPr>
+        <p:txBody>
+          <a:bodyPr xmlns:a="http://schemas.openxmlformats.org/drawingml/2006/main" anchor="b"/>
+          <a:lstStyle xmlns:a="http://schemas.openxmlformats.org/drawingml/2006/main"/>
+          <a:p xmlns:a="http://schemas.openxmlformats.org/drawingml/2006/main">
+            <a:pPr algn="l">
+              <a:buNone/>
+              <a:defRPr sz="4650" b="1">
+                <a:solidFill>
+                  <a:srgbClr val="000000"/>
+                </a:solidFill>
+                <a:latin typeface="Helvetica Neue"/>
+                <a:ea typeface="Helvetica Neue"/>
+                <a:cs typeface="Helvetica Neue"/>
+              </a:defRPr>
+            </a:pPr>
+            <a:r>
+              <a:rPr sz="4650" b="1">
+                <a:solidFill>
+                  <a:srgbClr val="000000"/>
+                </a:solidFill>
+                <a:latin typeface="Helvetica Neue"/>
+                <a:ea typeface="Helvetica Neue"/>
+                <a:cs typeface="Helvetica Neue"/>
+              </a:rPr>
+              <a:t>A private journey agent judges can verify end to end</a:t>
+            </a:r>
+          </a:p>
+        </p:txBody>
+      </p:sp>
+      <p:sp>
+        <p:nvSpPr>
+          <p:cNvPr id="3" name="">
+            <a:extLst xmlns:a="http://schemas.openxmlformats.org/drawingml/2006/main">
+              <a:ext uri="{FF2B5EF4-FFF2-40B4-BE49-F238E27FC236}">
+                <a16:creationId xmlns:a16="http://schemas.microsoft.com/office/drawing/2014/main" id="{BDC4202C-0065-4556-A3DE-2BB9C475E604}"/>
+              </a:ext>
+            </a:extLst>
+          </p:cNvPr>
+          <p:cNvSpPr>
+            <a:spLocks xmlns:a="http://schemas.openxmlformats.org/drawingml/2006/main" noGrp="1"/>
+          </p:cNvSpPr>
+          <p:nvPr/>
+        </p:nvSpPr>
+        <p:spPr>
+          <a:xfrm xmlns:a="http://schemas.openxmlformats.org/drawingml/2006/main">
+            <a:off x="400050" y="4171950"/>
+            <a:ext cx="11401425" cy="28575"/>
+          </a:xfrm>
+          <a:prstGeom xmlns:a="http://schemas.openxmlformats.org/drawingml/2006/main" prst="rect">
+            <a:avLst/>
+          </a:prstGeom>
+          <a:solidFill xmlns:a="http://schemas.openxmlformats.org/drawingml/2006/main">
+            <a:srgbClr val="3D8DFF"/>
+          </a:solidFill>
+          <a:ln xmlns:a="http://schemas.openxmlformats.org/drawingml/2006/main" w="0">
+            <a:solidFill>
+              <a:srgbClr val="3D8DFF"/>
+            </a:solidFill>
+            <a:prstDash val="solid"/>
+          </a:ln>
+        </p:spPr>
+      </p:sp>
+      <p:sp>
+        <p:nvSpPr>
+          <p:cNvPr id="4" name="">
+            <a:extLst xmlns:a="http://schemas.openxmlformats.org/drawingml/2006/main">
+              <a:ext uri="{FF2B5EF4-FFF2-40B4-BE49-F238E27FC236}">
+                <a16:creationId xmlns:a16="http://schemas.microsoft.com/office/drawing/2014/main" id="{76C16EE5-9BCD-470B-BCD9-C7A5E4804AAA}"/>
+              </a:ext>
+            </a:extLst>
+          </p:cNvPr>
+          <p:cNvSpPr>
+            <a:spLocks xmlns:a="http://schemas.openxmlformats.org/drawingml/2006/main" noGrp="1"/>
+          </p:cNvSpPr>
+          <p:nvPr/>
+        </p:nvSpPr>
+        <p:spPr>
+          <a:xfrm xmlns:a="http://schemas.openxmlformats.org/drawingml/2006/main">
+            <a:off x="400050" y="4686300"/>
+            <a:ext cx="1809750" cy="266700"/>
+          </a:xfrm>
+          <a:prstGeom xmlns:a="http://schemas.openxmlformats.org/drawingml/2006/main" prst="rect">
+            <a:avLst/>
+          </a:prstGeom>
+          <a:noFill xmlns:a="http://schemas.openxmlformats.org/drawingml/2006/main"/>
+          <a:ln xmlns:a="http://schemas.openxmlformats.org/drawingml/2006/main" w="0">
+            <a:noFill/>
+            <a:prstDash val="solid"/>
+          </a:ln>
+        </p:spPr>
+        <p:txBody>
+          <a:bodyPr xmlns:a="http://schemas.openxmlformats.org/drawingml/2006/main" anchor="t"/>
+          <a:lstStyle xmlns:a="http://schemas.openxmlformats.org/drawingml/2006/main"/>
+          <a:p xmlns:a="http://schemas.openxmlformats.org/drawingml/2006/main">
+            <a:pPr algn="l">
+              <a:buNone/>
+              <a:defRPr sz="1350" b="1">
+                <a:solidFill>
+                  <a:srgbClr val="5F6368"/>
+                </a:solidFill>
+                <a:latin typeface="Helvetica Neue"/>
+                <a:ea typeface="Helvetica Neue"/>
+                <a:cs typeface="Helvetica Neue"/>
+              </a:defRPr>
+            </a:pPr>
+            <a:r>
+              <a:rPr sz="1350" b="1">
+                <a:solidFill>
+                  <a:srgbClr val="5F6368"/>
+                </a:solidFill>
+                <a:latin typeface="Helvetica Neue"/>
+                <a:ea typeface="Helvetica Neue"/>
+                <a:cs typeface="Helvetica Neue"/>
+              </a:rPr>
+              <a:t>LIVE DEMO</a:t>
+            </a:r>
+          </a:p>
+        </p:txBody>
+      </p:sp>
+      <p:sp>
+        <p:nvSpPr>
+          <p:cNvPr id="5" name="">
+            <a:extLst xmlns:a="http://schemas.openxmlformats.org/drawingml/2006/main">
+              <a:ext uri="{FF2B5EF4-FFF2-40B4-BE49-F238E27FC236}">
+                <a16:creationId xmlns:a16="http://schemas.microsoft.com/office/drawing/2014/main" id="{87534AD9-E8AE-4F01-A2E8-70C2B5321255}"/>
+              </a:ext>
+            </a:extLst>
+          </p:cNvPr>
+          <p:cNvSpPr>
+            <a:spLocks xmlns:a="http://schemas.openxmlformats.org/drawingml/2006/main" noGrp="1"/>
+          </p:cNvSpPr>
+          <p:nvPr/>
+        </p:nvSpPr>
+        <p:spPr>
+          <a:xfrm xmlns:a="http://schemas.openxmlformats.org/drawingml/2006/main">
+            <a:off x="400050" y="5029200"/>
+            <a:ext cx="5048250" cy="361950"/>
+          </a:xfrm>
+          <a:prstGeom xmlns:a="http://schemas.openxmlformats.org/drawingml/2006/main" prst="rect">
+            <a:avLst/>
+          </a:prstGeom>
+          <a:noFill xmlns:a="http://schemas.openxmlformats.org/drawingml/2006/main"/>
+          <a:ln xmlns:a="http://schemas.openxmlformats.org/drawingml/2006/main" w="0">
+            <a:noFill/>
+            <a:prstDash val="solid"/>
+          </a:ln>
+        </p:spPr>
+        <p:txBody>
+          <a:bodyPr xmlns:a="http://schemas.openxmlformats.org/drawingml/2006/main" anchor="t"/>
+          <a:lstStyle xmlns:a="http://schemas.openxmlformats.org/drawingml/2006/main"/>
+          <a:p xmlns:a="http://schemas.openxmlformats.org/drawingml/2006/main">
+            <a:pPr algn="l">
+              <a:buNone/>
+              <a:defRPr sz="1650" b="1">
+                <a:solidFill>
+                  <a:srgbClr val="000000"/>
+                </a:solidFill>
+                <a:latin typeface="Helvetica Neue"/>
+                <a:ea typeface="Helvetica Neue"/>
+                <a:cs typeface="Helvetica Neue"/>
+              </a:defRPr>
+            </a:pPr>
+            <a:r>
+              <a:rPr sz="1650" b="1">
+                <a:solidFill>
+                  <a:srgbClr val="000000"/>
+                </a:solidFill>
+                <a:latin typeface="Helvetica Neue"/>
+                <a:ea typeface="Helvetica Neue"/>
+                <a:cs typeface="Helvetica Neue"/>
+              </a:rPr>
+              <a:t>rc-5ec89b08f896792e.radeon.firstdg.ai</a:t>
+            </a:r>
+          </a:p>
+        </p:txBody>
+      </p:sp>
+      <p:sp>
+        <p:nvSpPr>
+          <p:cNvPr id="6" name="">
+            <a:extLst xmlns:a="http://schemas.openxmlformats.org/drawingml/2006/main">
+              <a:ext uri="{FF2B5EF4-FFF2-40B4-BE49-F238E27FC236}">
+                <a16:creationId xmlns:a16="http://schemas.microsoft.com/office/drawing/2014/main" id="{0C2F1CC4-B5EB-4D1C-B04F-68391AE6D6E2}"/>
+              </a:ext>
+            </a:extLst>
+          </p:cNvPr>
+          <p:cNvSpPr>
+            <a:spLocks xmlns:a="http://schemas.openxmlformats.org/drawingml/2006/main" noGrp="1"/>
+          </p:cNvSpPr>
+          <p:nvPr/>
+        </p:nvSpPr>
+        <p:spPr>
+          <a:xfrm xmlns:a="http://schemas.openxmlformats.org/drawingml/2006/main">
+            <a:off x="5810250" y="4686300"/>
+            <a:ext cx="2190750" cy="266700"/>
+          </a:xfrm>
+          <a:prstGeom xmlns:a="http://schemas.openxmlformats.org/drawingml/2006/main" prst="rect">
+            <a:avLst/>
+          </a:prstGeom>
+          <a:noFill xmlns:a="http://schemas.openxmlformats.org/drawingml/2006/main"/>
+          <a:ln xmlns:a="http://schemas.openxmlformats.org/drawingml/2006/main" w="0">
+            <a:noFill/>
+            <a:prstDash val="solid"/>
+          </a:ln>
+        </p:spPr>
+        <p:txBody>
+          <a:bodyPr xmlns:a="http://schemas.openxmlformats.org/drawingml/2006/main" anchor="t"/>
+          <a:lstStyle xmlns:a="http://schemas.openxmlformats.org/drawingml/2006/main"/>
+          <a:p xmlns:a="http://schemas.openxmlformats.org/drawingml/2006/main">
+            <a:pPr algn="l">
+              <a:buNone/>
+              <a:defRPr sz="1350" b="1">
+                <a:solidFill>
+                  <a:srgbClr val="5F6368"/>
+                </a:solidFill>
+                <a:latin typeface="Helvetica Neue"/>
+                <a:ea typeface="Helvetica Neue"/>
+                <a:cs typeface="Helvetica Neue"/>
+              </a:defRPr>
+            </a:pPr>
+            <a:r>
+              <a:rPr sz="1350" b="1">
+                <a:solidFill>
+                  <a:srgbClr val="5F6368"/>
+                </a:solidFill>
+                <a:latin typeface="Helvetica Neue"/>
+                <a:ea typeface="Helvetica Neue"/>
+                <a:cs typeface="Helvetica Neue"/>
+              </a:rPr>
+              <a:t>SOURCE + EVIDENCE</a:t>
+            </a:r>
+          </a:p>
+        </p:txBody>
+      </p:sp>
+      <p:sp>
+        <p:nvSpPr>
+          <p:cNvPr id="7" name="">
+            <a:extLst xmlns:a="http://schemas.openxmlformats.org/drawingml/2006/main">
+              <a:ext uri="{FF2B5EF4-FFF2-40B4-BE49-F238E27FC236}">
+                <a16:creationId xmlns:a16="http://schemas.microsoft.com/office/drawing/2014/main" id="{868E72D7-2616-4BDC-A191-8E67DEAD2797}"/>
+              </a:ext>
+            </a:extLst>
+          </p:cNvPr>
+          <p:cNvSpPr>
+            <a:spLocks xmlns:a="http://schemas.openxmlformats.org/drawingml/2006/main" noGrp="1"/>
+          </p:cNvSpPr>
+          <p:nvPr/>
+        </p:nvSpPr>
+        <p:spPr>
+          <a:xfrm xmlns:a="http://schemas.openxmlformats.org/drawingml/2006/main">
+            <a:off x="5810250" y="5029200"/>
+            <a:ext cx="5619750" cy="361950"/>
+          </a:xfrm>
+          <a:prstGeom xmlns:a="http://schemas.openxmlformats.org/drawingml/2006/main" prst="rect">
+            <a:avLst/>
+          </a:prstGeom>
+          <a:noFill xmlns:a="http://schemas.openxmlformats.org/drawingml/2006/main"/>
+          <a:ln xmlns:a="http://schemas.openxmlformats.org/drawingml/2006/main" w="0">
+            <a:noFill/>
+            <a:prstDash val="solid"/>
+          </a:ln>
+        </p:spPr>
+        <p:txBody>
+          <a:bodyPr xmlns:a="http://schemas.openxmlformats.org/drawingml/2006/main" anchor="t"/>
+          <a:lstStyle xmlns:a="http://schemas.openxmlformats.org/drawingml/2006/main"/>
+          <a:p xmlns:a="http://schemas.openxmlformats.org/drawingml/2006/main">
+            <a:pPr algn="l">
+              <a:buNone/>
+              <a:defRPr sz="1650" b="1">
+                <a:solidFill>
+                  <a:srgbClr val="000000"/>
+                </a:solidFill>
+                <a:latin typeface="Helvetica Neue"/>
+                <a:ea typeface="Helvetica Neue"/>
+                <a:cs typeface="Helvetica Neue"/>
+              </a:defRPr>
+            </a:pPr>
+            <a:r>
+              <a:rPr sz="1650" b="1">
+                <a:solidFill>
+                  <a:srgbClr val="000000"/>
+                </a:solidFill>
+                <a:latin typeface="Helvetica Neue"/>
+                <a:ea typeface="Helvetica Neue"/>
+                <a:cs typeface="Helvetica Neue"/>
+              </a:rPr>
+              <a:t>C2 f7ba681 · report 7f85a614 · PR #192</a:t>
+            </a:r>
+          </a:p>
+        </p:txBody>
+      </p:sp>
+      <p:sp>
+        <p:nvSpPr>
+          <p:cNvPr id="8" name="">
+            <a:extLst xmlns:a="http://schemas.openxmlformats.org/drawingml/2006/main">
+              <a:ext uri="{FF2B5EF4-FFF2-40B4-BE49-F238E27FC236}">
+                <a16:creationId xmlns:a16="http://schemas.microsoft.com/office/drawing/2014/main" id="{57741A7E-C6FC-4515-907D-D46F755CBE51}"/>
+              </a:ext>
+            </a:extLst>
+          </p:cNvPr>
+          <p:cNvSpPr>
+            <a:spLocks xmlns:a="http://schemas.openxmlformats.org/drawingml/2006/main" noGrp="1"/>
+          </p:cNvSpPr>
+          <p:nvPr/>
+        </p:nvSpPr>
+        <p:spPr>
+          <a:xfrm xmlns:a="http://schemas.openxmlformats.org/drawingml/2006/main">
+            <a:off x="400050" y="5848350"/>
+            <a:ext cx="11049000" cy="342900"/>
+          </a:xfrm>
+          <a:prstGeom xmlns:a="http://schemas.openxmlformats.org/drawingml/2006/main" prst="rect">
+            <a:avLst/>
+          </a:prstGeom>
+          <a:noFill xmlns:a="http://schemas.openxmlformats.org/drawingml/2006/main"/>
+          <a:ln xmlns:a="http://schemas.openxmlformats.org/drawingml/2006/main" w="0">
+            <a:noFill/>
+            <a:prstDash val="solid"/>
+          </a:ln>
+        </p:spPr>
+        <p:txBody>
+          <a:bodyPr xmlns:a="http://schemas.openxmlformats.org/drawingml/2006/main" anchor="t"/>
+          <a:lstStyle xmlns:a="http://schemas.openxmlformats.org/drawingml/2006/main"/>
+          <a:p xmlns:a="http://schemas.openxmlformats.org/drawingml/2006/main">
+            <a:pPr algn="l">
+              <a:buNone/>
+              <a:defRPr sz="1575" b="0">
+                <a:solidFill>
+                  <a:srgbClr val="5F6368"/>
+                </a:solidFill>
+                <a:latin typeface="Helvetica Neue"/>
+                <a:ea typeface="Helvetica Neue"/>
+                <a:cs typeface="Helvetica Neue"/>
+              </a:defRPr>
+            </a:pPr>
+            <a:r>
+              <a:rPr sz="1575" b="0">
+                <a:solidFill>
+                  <a:srgbClr val="5F6368"/>
+                </a:solidFill>
+                <a:latin typeface="Helvetica Neue"/>
+                <a:ea typeface="Helvetica Neue"/>
+                <a:cs typeface="Helvetica Neue"/>
+              </a:rPr>
+              <a:t>Local Radeon proof · accepted Flash A/B · optional Cloud API route · deterministic authority</a:t>
+            </a:r>
+          </a:p>
+        </p:txBody>
+      </p:sp>
+    </p:spTree>
+    <p:extLst>
+      <p:ext uri="{BB962C8B-B14F-4D97-AF65-F5344CB8AC3E}">
+        <p14:creationId xmlns:p14="http://schemas.microsoft.com/office/powerpoint/2010/main" val="755100413"/>
       </p:ext>
     </p:extLst>
   </p:cSld>
@@ -2479,6 +3071,7 @@
           <a:lstStyle xmlns:a="http://schemas.openxmlformats.org/drawingml/2006/main"/>
           <a:p xmlns:a="http://schemas.openxmlformats.org/drawingml/2006/main">
             <a:pPr algn="l">
+              <a:buNone/>
               <a:defRPr sz="2925" b="1">
                 <a:solidFill>
                   <a:srgbClr val="000000"/>
@@ -2535,6 +3128,7 @@
           <a:lstStyle xmlns:a="http://schemas.openxmlformats.org/drawingml/2006/main"/>
           <a:p xmlns:a="http://schemas.openxmlformats.org/drawingml/2006/main">
             <a:pPr algn="r">
+              <a:buNone/>
               <a:defRPr sz="1050" b="0">
                 <a:solidFill>
                   <a:srgbClr val="5F6368"/>
@@ -2591,6 +3185,7 @@
           <a:lstStyle xmlns:a="http://schemas.openxmlformats.org/drawingml/2006/main"/>
           <a:p xmlns:a="http://schemas.openxmlformats.org/drawingml/2006/main">
             <a:pPr algn="l">
+              <a:buNone/>
               <a:defRPr sz="2025" b="1">
                 <a:solidFill>
                   <a:srgbClr val="000000"/>
@@ -2647,6 +3242,7 @@
           <a:lstStyle xmlns:a="http://schemas.openxmlformats.org/drawingml/2006/main"/>
           <a:p xmlns:a="http://schemas.openxmlformats.org/drawingml/2006/main">
             <a:pPr algn="l">
+              <a:buNone/>
               <a:defRPr sz="1575" b="0">
                 <a:solidFill>
                   <a:srgbClr val="5F6368"/>
@@ -2703,6 +3299,7 @@
           <a:lstStyle xmlns:a="http://schemas.openxmlformats.org/drawingml/2006/main"/>
           <a:p xmlns:a="http://schemas.openxmlformats.org/drawingml/2006/main">
             <a:pPr algn="l">
+              <a:buNone/>
               <a:defRPr sz="1350" b="1">
                 <a:solidFill>
                   <a:srgbClr val="3D8DFF"/>
@@ -2759,6 +3356,7 @@
           <a:lstStyle xmlns:a="http://schemas.openxmlformats.org/drawingml/2006/main"/>
           <a:p xmlns:a="http://schemas.openxmlformats.org/drawingml/2006/main">
             <a:pPr algn="l">
+              <a:buNone/>
               <a:defRPr sz="1500" b="0">
                 <a:solidFill>
                   <a:srgbClr val="000000"/>
@@ -2815,6 +3413,7 @@
           <a:lstStyle xmlns:a="http://schemas.openxmlformats.org/drawingml/2006/main"/>
           <a:p xmlns:a="http://schemas.openxmlformats.org/drawingml/2006/main">
             <a:pPr algn="l">
+              <a:buNone/>
               <a:defRPr sz="1350" b="1">
                 <a:solidFill>
                   <a:srgbClr val="3D8DFF"/>
@@ -2871,6 +3470,7 @@
           <a:lstStyle xmlns:a="http://schemas.openxmlformats.org/drawingml/2006/main"/>
           <a:p xmlns:a="http://schemas.openxmlformats.org/drawingml/2006/main">
             <a:pPr algn="l">
+              <a:buNone/>
               <a:defRPr sz="1500" b="0">
                 <a:solidFill>
                   <a:srgbClr val="000000"/>
@@ -2927,6 +3527,7 @@
           <a:lstStyle xmlns:a="http://schemas.openxmlformats.org/drawingml/2006/main"/>
           <a:p xmlns:a="http://schemas.openxmlformats.org/drawingml/2006/main">
             <a:pPr algn="l">
+              <a:buNone/>
               <a:defRPr sz="1350" b="1">
                 <a:solidFill>
                   <a:srgbClr val="3D8DFF"/>
@@ -2983,6 +3584,7 @@
           <a:lstStyle xmlns:a="http://schemas.openxmlformats.org/drawingml/2006/main"/>
           <a:p xmlns:a="http://schemas.openxmlformats.org/drawingml/2006/main">
             <a:pPr algn="l">
+              <a:buNone/>
               <a:defRPr sz="1500" b="0">
                 <a:solidFill>
                   <a:srgbClr val="000000"/>
@@ -3039,6 +3641,7 @@
           <a:lstStyle xmlns:a="http://schemas.openxmlformats.org/drawingml/2006/main"/>
           <a:p xmlns:a="http://schemas.openxmlformats.org/drawingml/2006/main">
             <a:pPr algn="l">
+              <a:buNone/>
               <a:defRPr sz="1350" b="1">
                 <a:solidFill>
                   <a:srgbClr val="3D8DFF"/>
@@ -3095,6 +3698,7 @@
           <a:lstStyle xmlns:a="http://schemas.openxmlformats.org/drawingml/2006/main"/>
           <a:p xmlns:a="http://schemas.openxmlformats.org/drawingml/2006/main">
             <a:pPr algn="l">
+              <a:buNone/>
               <a:defRPr sz="1500" b="0">
                 <a:solidFill>
                   <a:srgbClr val="000000"/>
@@ -3155,14 +3759,14 @@
       </p:sp>
       <p:pic>
         <p:nvPicPr>
-          <p:cNvPr id="29" name=""/>
+          <p:cNvPr id="31" name=""/>
           <p:cNvPicPr>
             <a:picLocks xmlns:a="http://schemas.openxmlformats.org/drawingml/2006/main" noChangeAspect="1"/>
           </p:cNvPicPr>
           <p:nvPr/>
         </p:nvPicPr>
         <p:blipFill>
-          <a:blip xmlns:r="http://schemas.openxmlformats.org/officeDocument/2006/relationships" xmlns:a="http://schemas.openxmlformats.org/drawingml/2006/main" r:embed="R8a62a95f1c684de1"/>
+          <a:blip xmlns:r="http://schemas.openxmlformats.org/officeDocument/2006/relationships" xmlns:a="http://schemas.openxmlformats.org/drawingml/2006/main" r:embed="R78d67ec14c7b4d18"/>
           <a:stretch xmlns:a="http://schemas.openxmlformats.org/drawingml/2006/main"/>
         </p:blipFill>
         <p:spPr>
@@ -3210,6 +3814,7 @@
           <a:lstStyle xmlns:a="http://schemas.openxmlformats.org/drawingml/2006/main"/>
           <a:p xmlns:a="http://schemas.openxmlformats.org/drawingml/2006/main">
             <a:pPr algn="r">
+              <a:buNone/>
               <a:defRPr sz="1125" b="1">
                 <a:solidFill>
                   <a:srgbClr val="5F6368"/>
@@ -3295,6 +3900,7 @@
           <a:lstStyle xmlns:a="http://schemas.openxmlformats.org/drawingml/2006/main"/>
           <a:p xmlns:a="http://schemas.openxmlformats.org/drawingml/2006/main">
             <a:pPr algn="l">
+              <a:buNone/>
               <a:defRPr sz="2925" b="1">
                 <a:solidFill>
                   <a:srgbClr val="000000"/>
@@ -3351,6 +3957,7 @@
           <a:lstStyle xmlns:a="http://schemas.openxmlformats.org/drawingml/2006/main"/>
           <a:p xmlns:a="http://schemas.openxmlformats.org/drawingml/2006/main">
             <a:pPr algn="r">
+              <a:buNone/>
               <a:defRPr sz="1050" b="0">
                 <a:solidFill>
                   <a:srgbClr val="5F6368"/>
@@ -3407,6 +4014,7 @@
           <a:lstStyle xmlns:a="http://schemas.openxmlformats.org/drawingml/2006/main"/>
           <a:p xmlns:a="http://schemas.openxmlformats.org/drawingml/2006/main">
             <a:pPr algn="l">
+              <a:buNone/>
               <a:defRPr sz="1725" b="0">
                 <a:solidFill>
                   <a:srgbClr val="5F6368"/>
@@ -3432,7 +4040,7 @@
       </p:sp>
       <p:cxnSp>
         <p:nvCxnSpPr>
-          <p:cNvPr id="25" name=""/>
+          <p:cNvPr id="37" name=""/>
           <p:cNvCxnSpPr/>
           <p:nvPr/>
         </p:nvCxnSpPr>
@@ -3454,7 +4062,7 @@
       </p:cxnSp>
       <p:cxnSp>
         <p:nvCxnSpPr>
-          <p:cNvPr id="26" name=""/>
+          <p:cNvPr id="38" name=""/>
           <p:cNvCxnSpPr/>
           <p:nvPr/>
         </p:nvCxnSpPr>
@@ -3476,7 +4084,7 @@
       </p:cxnSp>
       <p:cxnSp>
         <p:nvCxnSpPr>
-          <p:cNvPr id="27" name=""/>
+          <p:cNvPr id="39" name=""/>
           <p:cNvCxnSpPr/>
           <p:nvPr/>
         </p:nvCxnSpPr>
@@ -3564,6 +4172,7 @@
           <a:lstStyle xmlns:a="http://schemas.openxmlformats.org/drawingml/2006/main"/>
           <a:p xmlns:a="http://schemas.openxmlformats.org/drawingml/2006/main">
             <a:pPr algn="l">
+              <a:buNone/>
               <a:defRPr sz="1800" b="1">
                 <a:solidFill>
                   <a:srgbClr val="000000"/>
@@ -3620,6 +4229,7 @@
           <a:lstStyle xmlns:a="http://schemas.openxmlformats.org/drawingml/2006/main"/>
           <a:p xmlns:a="http://schemas.openxmlformats.org/drawingml/2006/main">
             <a:pPr algn="l">
+              <a:buNone/>
               <a:defRPr sz="1350" b="0">
                 <a:solidFill>
                   <a:srgbClr val="5F6368"/>
@@ -3643,6 +4253,7 @@
           </a:p>
           <a:p xmlns:a="http://schemas.openxmlformats.org/drawingml/2006/main">
             <a:pPr algn="l">
+              <a:buNone/>
               <a:defRPr sz="1350" b="0">
                 <a:solidFill>
                   <a:srgbClr val="5F6368"/>
@@ -3734,6 +4345,7 @@
           <a:lstStyle xmlns:a="http://schemas.openxmlformats.org/drawingml/2006/main"/>
           <a:p xmlns:a="http://schemas.openxmlformats.org/drawingml/2006/main">
             <a:pPr algn="l">
+              <a:buNone/>
               <a:defRPr sz="1800" b="1">
                 <a:solidFill>
                   <a:srgbClr val="000000"/>
@@ -3790,6 +4402,7 @@
           <a:lstStyle xmlns:a="http://schemas.openxmlformats.org/drawingml/2006/main"/>
           <a:p xmlns:a="http://schemas.openxmlformats.org/drawingml/2006/main">
             <a:pPr algn="l">
+              <a:buNone/>
               <a:defRPr sz="1350" b="0">
                 <a:solidFill>
                   <a:srgbClr val="5F6368"/>
@@ -3813,6 +4426,7 @@
           </a:p>
           <a:p xmlns:a="http://schemas.openxmlformats.org/drawingml/2006/main">
             <a:pPr algn="l">
+              <a:buNone/>
               <a:defRPr sz="1350" b="0">
                 <a:solidFill>
                   <a:srgbClr val="5F6368"/>
@@ -3904,6 +4518,7 @@
           <a:lstStyle xmlns:a="http://schemas.openxmlformats.org/drawingml/2006/main"/>
           <a:p xmlns:a="http://schemas.openxmlformats.org/drawingml/2006/main">
             <a:pPr algn="l">
+              <a:buNone/>
               <a:defRPr sz="1800" b="1">
                 <a:solidFill>
                   <a:srgbClr val="000000"/>
@@ -3960,6 +4575,7 @@
           <a:lstStyle xmlns:a="http://schemas.openxmlformats.org/drawingml/2006/main"/>
           <a:p xmlns:a="http://schemas.openxmlformats.org/drawingml/2006/main">
             <a:pPr algn="l">
+              <a:buNone/>
               <a:defRPr sz="1350" b="0">
                 <a:solidFill>
                   <a:srgbClr val="5F6368"/>
@@ -3983,6 +4599,7 @@
           </a:p>
           <a:p xmlns:a="http://schemas.openxmlformats.org/drawingml/2006/main">
             <a:pPr algn="l">
+              <a:buNone/>
               <a:defRPr sz="1350" b="0">
                 <a:solidFill>
                   <a:srgbClr val="5F6368"/>
@@ -4074,6 +4691,7 @@
           <a:lstStyle xmlns:a="http://schemas.openxmlformats.org/drawingml/2006/main"/>
           <a:p xmlns:a="http://schemas.openxmlformats.org/drawingml/2006/main">
             <a:pPr algn="l">
+              <a:buNone/>
               <a:defRPr sz="1800" b="1">
                 <a:solidFill>
                   <a:srgbClr val="000000"/>
@@ -4130,6 +4748,7 @@
           <a:lstStyle xmlns:a="http://schemas.openxmlformats.org/drawingml/2006/main"/>
           <a:p xmlns:a="http://schemas.openxmlformats.org/drawingml/2006/main">
             <a:pPr algn="l">
+              <a:buNone/>
               <a:defRPr sz="1350" b="0">
                 <a:solidFill>
                   <a:srgbClr val="5F6368"/>
@@ -4153,6 +4772,7 @@
           </a:p>
           <a:p xmlns:a="http://schemas.openxmlformats.org/drawingml/2006/main">
             <a:pPr algn="l">
+              <a:buNone/>
               <a:defRPr sz="1350" b="0">
                 <a:solidFill>
                   <a:srgbClr val="5F6368"/>
@@ -4242,6 +4862,7 @@
           <a:lstStyle xmlns:a="http://schemas.openxmlformats.org/drawingml/2006/main"/>
           <a:p xmlns:a="http://schemas.openxmlformats.org/drawingml/2006/main">
             <a:pPr algn="l">
+              <a:buNone/>
               <a:defRPr sz="1425" b="1">
                 <a:solidFill>
                   <a:srgbClr val="000000"/>
@@ -4260,7 +4881,7 @@
                 <a:ea typeface="Helvetica Neue"/>
                 <a:cs typeface="Helvetica Neue"/>
               </a:rPr>
-              <a:t>Local-only boundary</a:t>
+              <a:t>Base-100 local boundary</a:t>
             </a:r>
           </a:p>
         </p:txBody>
@@ -4298,6 +4919,7 @@
           <a:lstStyle xmlns:a="http://schemas.openxmlformats.org/drawingml/2006/main"/>
           <a:p xmlns:a="http://schemas.openxmlformats.org/drawingml/2006/main">
             <a:pPr algn="l">
+              <a:buNone/>
               <a:defRPr sz="1425" b="0">
                 <a:solidFill>
                   <a:srgbClr val="5F6368"/>
@@ -4316,7 +4938,7 @@
                 <a:ea typeface="Helvetica Neue"/>
                 <a:cs typeface="Helvetica Neue"/>
               </a:rPr>
-              <a:t>No remote inference API · no arbitrary shell/network/SQL tools · no confirmation capability exposed to the browser</a:t>
+              <a:t>Core path: no remote inference API · no arbitrary shell/network/SQL tools · no confirmation capability exposed to the browser</a:t>
             </a:r>
           </a:p>
         </p:txBody>
@@ -4383,6 +5005,7 @@
           <a:lstStyle xmlns:a="http://schemas.openxmlformats.org/drawingml/2006/main"/>
           <a:p xmlns:a="http://schemas.openxmlformats.org/drawingml/2006/main">
             <a:pPr algn="l">
+              <a:buNone/>
               <a:defRPr sz="2925" b="1">
                 <a:solidFill>
                   <a:srgbClr val="000000"/>
@@ -4439,6 +5062,7 @@
           <a:lstStyle xmlns:a="http://schemas.openxmlformats.org/drawingml/2006/main"/>
           <a:p xmlns:a="http://schemas.openxmlformats.org/drawingml/2006/main">
             <a:pPr algn="r">
+              <a:buNone/>
               <a:defRPr sz="1050" b="0">
                 <a:solidFill>
                   <a:srgbClr val="5F6368"/>
@@ -4495,6 +5119,7 @@
           <a:lstStyle xmlns:a="http://schemas.openxmlformats.org/drawingml/2006/main"/>
           <a:p xmlns:a="http://schemas.openxmlformats.org/drawingml/2006/main">
             <a:pPr algn="l">
+              <a:buNone/>
               <a:defRPr sz="1425" b="1">
                 <a:solidFill>
                   <a:srgbClr val="3D8DFF"/>
@@ -4551,6 +5176,7 @@
           <a:lstStyle xmlns:a="http://schemas.openxmlformats.org/drawingml/2006/main"/>
           <a:p xmlns:a="http://schemas.openxmlformats.org/drawingml/2006/main">
             <a:pPr algn="l">
+              <a:buNone/>
               <a:defRPr sz="1950" b="1">
                 <a:solidFill>
                   <a:srgbClr val="000000"/>
@@ -4607,6 +5233,7 @@
           <a:lstStyle xmlns:a="http://schemas.openxmlformats.org/drawingml/2006/main"/>
           <a:p xmlns:a="http://schemas.openxmlformats.org/drawingml/2006/main">
             <a:pPr algn="l">
+              <a:buNone/>
               <a:defRPr sz="1350" b="0">
                 <a:solidFill>
                   <a:srgbClr val="5F6368"/>
@@ -4696,6 +5323,7 @@
           <a:lstStyle xmlns:a="http://schemas.openxmlformats.org/drawingml/2006/main"/>
           <a:p xmlns:a="http://schemas.openxmlformats.org/drawingml/2006/main">
             <a:pPr algn="l">
+              <a:buNone/>
               <a:defRPr sz="1425" b="1">
                 <a:solidFill>
                   <a:srgbClr val="3D8DFF"/>
@@ -4752,6 +5380,7 @@
           <a:lstStyle xmlns:a="http://schemas.openxmlformats.org/drawingml/2006/main"/>
           <a:p xmlns:a="http://schemas.openxmlformats.org/drawingml/2006/main">
             <a:pPr algn="l">
+              <a:buNone/>
               <a:defRPr sz="1950" b="1">
                 <a:solidFill>
                   <a:srgbClr val="000000"/>
@@ -4808,6 +5437,7 @@
           <a:lstStyle xmlns:a="http://schemas.openxmlformats.org/drawingml/2006/main"/>
           <a:p xmlns:a="http://schemas.openxmlformats.org/drawingml/2006/main">
             <a:pPr algn="l">
+              <a:buNone/>
               <a:defRPr sz="1350" b="0">
                 <a:solidFill>
                   <a:srgbClr val="5F6368"/>
@@ -4897,6 +5527,7 @@
           <a:lstStyle xmlns:a="http://schemas.openxmlformats.org/drawingml/2006/main"/>
           <a:p xmlns:a="http://schemas.openxmlformats.org/drawingml/2006/main">
             <a:pPr algn="l">
+              <a:buNone/>
               <a:defRPr sz="1425" b="1">
                 <a:solidFill>
                   <a:srgbClr val="3D8DFF"/>
@@ -4953,6 +5584,7 @@
           <a:lstStyle xmlns:a="http://schemas.openxmlformats.org/drawingml/2006/main"/>
           <a:p xmlns:a="http://schemas.openxmlformats.org/drawingml/2006/main">
             <a:pPr algn="l">
+              <a:buNone/>
               <a:defRPr sz="1950" b="1">
                 <a:solidFill>
                   <a:srgbClr val="000000"/>
@@ -5009,6 +5641,7 @@
           <a:lstStyle xmlns:a="http://schemas.openxmlformats.org/drawingml/2006/main"/>
           <a:p xmlns:a="http://schemas.openxmlformats.org/drawingml/2006/main">
             <a:pPr algn="l">
+              <a:buNone/>
               <a:defRPr sz="1350" b="0">
                 <a:solidFill>
                   <a:srgbClr val="5F6368"/>
@@ -5098,6 +5731,7 @@
           <a:lstStyle xmlns:a="http://schemas.openxmlformats.org/drawingml/2006/main"/>
           <a:p xmlns:a="http://schemas.openxmlformats.org/drawingml/2006/main">
             <a:pPr algn="l">
+              <a:buNone/>
               <a:defRPr sz="1425" b="1">
                 <a:solidFill>
                   <a:srgbClr val="3D8DFF"/>
@@ -5154,6 +5788,7 @@
           <a:lstStyle xmlns:a="http://schemas.openxmlformats.org/drawingml/2006/main"/>
           <a:p xmlns:a="http://schemas.openxmlformats.org/drawingml/2006/main">
             <a:pPr algn="l">
+              <a:buNone/>
               <a:defRPr sz="1950" b="1">
                 <a:solidFill>
                   <a:srgbClr val="000000"/>
@@ -5210,6 +5845,7 @@
           <a:lstStyle xmlns:a="http://schemas.openxmlformats.org/drawingml/2006/main"/>
           <a:p xmlns:a="http://schemas.openxmlformats.org/drawingml/2006/main">
             <a:pPr algn="l">
+              <a:buNone/>
               <a:defRPr sz="1350" b="0">
                 <a:solidFill>
                   <a:srgbClr val="5F6368"/>
@@ -5299,6 +5935,7 @@
           <a:lstStyle xmlns:a="http://schemas.openxmlformats.org/drawingml/2006/main"/>
           <a:p xmlns:a="http://schemas.openxmlformats.org/drawingml/2006/main">
             <a:pPr algn="l">
+              <a:buNone/>
               <a:defRPr sz="1425" b="1">
                 <a:solidFill>
                   <a:srgbClr val="3D8DFF"/>
@@ -5355,6 +5992,7 @@
           <a:lstStyle xmlns:a="http://schemas.openxmlformats.org/drawingml/2006/main"/>
           <a:p xmlns:a="http://schemas.openxmlformats.org/drawingml/2006/main">
             <a:pPr algn="l">
+              <a:buNone/>
               <a:defRPr sz="1950" b="1">
                 <a:solidFill>
                   <a:srgbClr val="000000"/>
@@ -5411,6 +6049,7 @@
           <a:lstStyle xmlns:a="http://schemas.openxmlformats.org/drawingml/2006/main"/>
           <a:p xmlns:a="http://schemas.openxmlformats.org/drawingml/2006/main">
             <a:pPr algn="l">
+              <a:buNone/>
               <a:defRPr sz="1350" b="0">
                 <a:solidFill>
                   <a:srgbClr val="5F6368"/>
@@ -5502,6 +6141,7 @@
           <a:lstStyle xmlns:a="http://schemas.openxmlformats.org/drawingml/2006/main"/>
           <a:p xmlns:a="http://schemas.openxmlformats.org/drawingml/2006/main">
             <a:pPr algn="ctr">
+              <a:buNone/>
               <a:defRPr sz="1500" b="1">
                 <a:solidFill>
                   <a:srgbClr val="000000"/>
@@ -5587,6 +6227,7 @@
           <a:lstStyle xmlns:a="http://schemas.openxmlformats.org/drawingml/2006/main"/>
           <a:p xmlns:a="http://schemas.openxmlformats.org/drawingml/2006/main">
             <a:pPr algn="l">
+              <a:buNone/>
               <a:defRPr sz="2925" b="1">
                 <a:solidFill>
                   <a:srgbClr val="000000"/>
@@ -5643,6 +6284,7 @@
           <a:lstStyle xmlns:a="http://schemas.openxmlformats.org/drawingml/2006/main"/>
           <a:p xmlns:a="http://schemas.openxmlformats.org/drawingml/2006/main">
             <a:pPr algn="r">
+              <a:buNone/>
               <a:defRPr sz="1050" b="0">
                 <a:solidFill>
                   <a:srgbClr val="5F6368"/>
@@ -5703,14 +6345,14 @@
       </p:sp>
       <p:pic>
         <p:nvPicPr>
-          <p:cNvPr id="14" name=""/>
+          <p:cNvPr id="16" name=""/>
           <p:cNvPicPr>
             <a:picLocks xmlns:a="http://schemas.openxmlformats.org/drawingml/2006/main" noChangeAspect="1"/>
           </p:cNvPicPr>
           <p:nvPr/>
         </p:nvPicPr>
         <p:blipFill>
-          <a:blip xmlns:r="http://schemas.openxmlformats.org/officeDocument/2006/relationships" xmlns:a="http://schemas.openxmlformats.org/drawingml/2006/main" r:embed="R32426ef12f9e487a"/>
+          <a:blip xmlns:r="http://schemas.openxmlformats.org/officeDocument/2006/relationships" xmlns:a="http://schemas.openxmlformats.org/drawingml/2006/main" r:embed="R0fd84bb72d8847a1"/>
           <a:srcRect xmlns:a="http://schemas.openxmlformats.org/drawingml/2006/main" l="0" t="150" r="0" b="150"/>
           <a:stretch xmlns:a="http://schemas.openxmlformats.org/drawingml/2006/main">
             <a:fillRect l="0" t="0" r="0" b="0"/>
@@ -5761,6 +6403,7 @@
           <a:lstStyle xmlns:a="http://schemas.openxmlformats.org/drawingml/2006/main"/>
           <a:p xmlns:a="http://schemas.openxmlformats.org/drawingml/2006/main">
             <a:pPr algn="l">
+              <a:buNone/>
               <a:defRPr sz="1275" b="1">
                 <a:solidFill>
                   <a:srgbClr val="3D8DFF"/>
@@ -5817,6 +6460,7 @@
           <a:lstStyle xmlns:a="http://schemas.openxmlformats.org/drawingml/2006/main"/>
           <a:p xmlns:a="http://schemas.openxmlformats.org/drawingml/2006/main">
             <a:pPr algn="l">
+              <a:buNone/>
               <a:defRPr sz="1350" b="0">
                 <a:solidFill>
                   <a:srgbClr val="000000"/>
@@ -5873,6 +6517,7 @@
           <a:lstStyle xmlns:a="http://schemas.openxmlformats.org/drawingml/2006/main"/>
           <a:p xmlns:a="http://schemas.openxmlformats.org/drawingml/2006/main">
             <a:pPr algn="l">
+              <a:buNone/>
               <a:defRPr sz="1275" b="1">
                 <a:solidFill>
                   <a:srgbClr val="3D8DFF"/>
@@ -5929,6 +6574,7 @@
           <a:lstStyle xmlns:a="http://schemas.openxmlformats.org/drawingml/2006/main"/>
           <a:p xmlns:a="http://schemas.openxmlformats.org/drawingml/2006/main">
             <a:pPr algn="l">
+              <a:buNone/>
               <a:defRPr sz="1350" b="0">
                 <a:solidFill>
                   <a:srgbClr val="000000"/>
@@ -5985,6 +6631,7 @@
           <a:lstStyle xmlns:a="http://schemas.openxmlformats.org/drawingml/2006/main"/>
           <a:p xmlns:a="http://schemas.openxmlformats.org/drawingml/2006/main">
             <a:pPr algn="l">
+              <a:buNone/>
               <a:defRPr sz="1275" b="1">
                 <a:solidFill>
                   <a:srgbClr val="3D8DFF"/>
@@ -6041,6 +6688,7 @@
           <a:lstStyle xmlns:a="http://schemas.openxmlformats.org/drawingml/2006/main"/>
           <a:p xmlns:a="http://schemas.openxmlformats.org/drawingml/2006/main">
             <a:pPr algn="l">
+              <a:buNone/>
               <a:defRPr sz="1350" b="0">
                 <a:solidFill>
                   <a:srgbClr val="000000"/>
@@ -6126,6 +6774,7 @@
           <a:lstStyle xmlns:a="http://schemas.openxmlformats.org/drawingml/2006/main"/>
           <a:p xmlns:a="http://schemas.openxmlformats.org/drawingml/2006/main">
             <a:pPr algn="l">
+              <a:buNone/>
               <a:defRPr sz="2925" b="1">
                 <a:solidFill>
                   <a:srgbClr val="000000"/>
@@ -6182,6 +6831,7 @@
           <a:lstStyle xmlns:a="http://schemas.openxmlformats.org/drawingml/2006/main"/>
           <a:p xmlns:a="http://schemas.openxmlformats.org/drawingml/2006/main">
             <a:pPr algn="r">
+              <a:buNone/>
               <a:defRPr sz="1050" b="0">
                 <a:solidFill>
                   <a:srgbClr val="5F6368"/>
@@ -6238,6 +6888,7 @@
           <a:lstStyle xmlns:a="http://schemas.openxmlformats.org/drawingml/2006/main"/>
           <a:p xmlns:a="http://schemas.openxmlformats.org/drawingml/2006/main">
             <a:pPr algn="l">
+              <a:buNone/>
               <a:defRPr sz="1725" b="0">
                 <a:solidFill>
                   <a:srgbClr val="5F6368"/>
@@ -6298,14 +6949,14 @@
       </p:sp>
       <p:pic>
         <p:nvPicPr>
-          <p:cNvPr id="16" name=""/>
+          <p:cNvPr id="19" name=""/>
           <p:cNvPicPr>
             <a:picLocks xmlns:a="http://schemas.openxmlformats.org/drawingml/2006/main" noChangeAspect="1"/>
           </p:cNvPicPr>
           <p:nvPr/>
         </p:nvPicPr>
         <p:blipFill>
-          <a:blip xmlns:r="http://schemas.openxmlformats.org/officeDocument/2006/relationships" xmlns:a="http://schemas.openxmlformats.org/drawingml/2006/main" r:embed="R6cc59d5c19a3413d"/>
+          <a:blip xmlns:r="http://schemas.openxmlformats.org/officeDocument/2006/relationships" xmlns:a="http://schemas.openxmlformats.org/drawingml/2006/main" r:embed="R480631ad1f814283"/>
           <a:srcRect xmlns:a="http://schemas.openxmlformats.org/drawingml/2006/main" l="0" t="902" r="0" b="902"/>
           <a:stretch xmlns:a="http://schemas.openxmlformats.org/drawingml/2006/main">
             <a:fillRect l="0" t="0" r="0" b="0"/>
@@ -6360,14 +7011,14 @@
       </p:sp>
       <p:pic>
         <p:nvPicPr>
-          <p:cNvPr id="18" name=""/>
+          <p:cNvPr id="21" name=""/>
           <p:cNvPicPr>
             <a:picLocks xmlns:a="http://schemas.openxmlformats.org/drawingml/2006/main" noChangeAspect="1"/>
           </p:cNvPicPr>
           <p:nvPr/>
         </p:nvPicPr>
         <p:blipFill>
-          <a:blip xmlns:r="http://schemas.openxmlformats.org/officeDocument/2006/relationships" xmlns:a="http://schemas.openxmlformats.org/drawingml/2006/main" r:embed="Ra6f010a49a87408c"/>
+          <a:blip xmlns:r="http://schemas.openxmlformats.org/officeDocument/2006/relationships" xmlns:a="http://schemas.openxmlformats.org/drawingml/2006/main" r:embed="R8416048e9d864233"/>
           <a:stretch xmlns:a="http://schemas.openxmlformats.org/drawingml/2006/main"/>
         </p:blipFill>
         <p:spPr>
@@ -6415,6 +7066,7 @@
           <a:lstStyle xmlns:a="http://schemas.openxmlformats.org/drawingml/2006/main"/>
           <a:p xmlns:a="http://schemas.openxmlformats.org/drawingml/2006/main">
             <a:pPr algn="l">
+              <a:buNone/>
               <a:defRPr sz="1350" b="1">
                 <a:solidFill>
                   <a:srgbClr val="3D8DFF"/>
@@ -6471,6 +7123,7 @@
           <a:lstStyle xmlns:a="http://schemas.openxmlformats.org/drawingml/2006/main"/>
           <a:p xmlns:a="http://schemas.openxmlformats.org/drawingml/2006/main">
             <a:pPr algn="l">
+              <a:buNone/>
               <a:defRPr sz="1650" b="1">
                 <a:solidFill>
                   <a:srgbClr val="000000"/>
@@ -6527,6 +7180,7 @@
           <a:lstStyle xmlns:a="http://schemas.openxmlformats.org/drawingml/2006/main"/>
           <a:p xmlns:a="http://schemas.openxmlformats.org/drawingml/2006/main">
             <a:pPr algn="l">
+              <a:buNone/>
               <a:defRPr sz="1350" b="1">
                 <a:solidFill>
                   <a:srgbClr val="3D8DFF"/>
@@ -6583,6 +7237,7 @@
           <a:lstStyle xmlns:a="http://schemas.openxmlformats.org/drawingml/2006/main"/>
           <a:p xmlns:a="http://schemas.openxmlformats.org/drawingml/2006/main">
             <a:pPr algn="l">
+              <a:buNone/>
               <a:defRPr sz="1650" b="1">
                 <a:solidFill>
                   <a:srgbClr val="000000"/>
@@ -6668,6 +7323,7 @@
           <a:lstStyle xmlns:a="http://schemas.openxmlformats.org/drawingml/2006/main"/>
           <a:p xmlns:a="http://schemas.openxmlformats.org/drawingml/2006/main">
             <a:pPr algn="l">
+              <a:buNone/>
               <a:defRPr sz="2925" b="1">
                 <a:solidFill>
                   <a:srgbClr val="000000"/>
@@ -6724,6 +7380,7 @@
           <a:lstStyle xmlns:a="http://schemas.openxmlformats.org/drawingml/2006/main"/>
           <a:p xmlns:a="http://schemas.openxmlformats.org/drawingml/2006/main">
             <a:pPr algn="r">
+              <a:buNone/>
               <a:defRPr sz="1050" b="0">
                 <a:solidFill>
                   <a:srgbClr val="5F6368"/>
@@ -6780,6 +7437,7 @@
           <a:lstStyle xmlns:a="http://schemas.openxmlformats.org/drawingml/2006/main"/>
           <a:p xmlns:a="http://schemas.openxmlformats.org/drawingml/2006/main">
             <a:pPr algn="l">
+              <a:buNone/>
               <a:defRPr sz="1725" b="0">
                 <a:solidFill>
                   <a:srgbClr val="5F6368"/>
@@ -6871,6 +7529,7 @@
           <a:lstStyle xmlns:a="http://schemas.openxmlformats.org/drawingml/2006/main"/>
           <a:p xmlns:a="http://schemas.openxmlformats.org/drawingml/2006/main">
             <a:pPr algn="l">
+              <a:buNone/>
               <a:defRPr sz="1350" b="1">
                 <a:solidFill>
                   <a:srgbClr val="5F6368"/>
@@ -6927,6 +7586,7 @@
           <a:lstStyle xmlns:a="http://schemas.openxmlformats.org/drawingml/2006/main"/>
           <a:p xmlns:a="http://schemas.openxmlformats.org/drawingml/2006/main">
             <a:pPr algn="l">
+              <a:buNone/>
               <a:defRPr sz="3150" b="1">
                 <a:solidFill>
                   <a:srgbClr val="000000"/>
@@ -6983,6 +7643,7 @@
           <a:lstStyle xmlns:a="http://schemas.openxmlformats.org/drawingml/2006/main"/>
           <a:p xmlns:a="http://schemas.openxmlformats.org/drawingml/2006/main">
             <a:pPr algn="l">
+              <a:buNone/>
               <a:defRPr sz="1275" b="0">
                 <a:solidFill>
                   <a:srgbClr val="5F6368"/>
@@ -7074,6 +7735,7 @@
           <a:lstStyle xmlns:a="http://schemas.openxmlformats.org/drawingml/2006/main"/>
           <a:p xmlns:a="http://schemas.openxmlformats.org/drawingml/2006/main">
             <a:pPr algn="l">
+              <a:buNone/>
               <a:defRPr sz="1350" b="1">
                 <a:solidFill>
                   <a:srgbClr val="5F6368"/>
@@ -7130,6 +7792,7 @@
           <a:lstStyle xmlns:a="http://schemas.openxmlformats.org/drawingml/2006/main"/>
           <a:p xmlns:a="http://schemas.openxmlformats.org/drawingml/2006/main">
             <a:pPr algn="l">
+              <a:buNone/>
               <a:defRPr sz="3150" b="1">
                 <a:solidFill>
                   <a:srgbClr val="000000"/>
@@ -7186,6 +7849,7 @@
           <a:lstStyle xmlns:a="http://schemas.openxmlformats.org/drawingml/2006/main"/>
           <a:p xmlns:a="http://schemas.openxmlformats.org/drawingml/2006/main">
             <a:pPr algn="l">
+              <a:buNone/>
               <a:defRPr sz="1275" b="0">
                 <a:solidFill>
                   <a:srgbClr val="5F6368"/>
@@ -7277,6 +7941,7 @@
           <a:lstStyle xmlns:a="http://schemas.openxmlformats.org/drawingml/2006/main"/>
           <a:p xmlns:a="http://schemas.openxmlformats.org/drawingml/2006/main">
             <a:pPr algn="l">
+              <a:buNone/>
               <a:defRPr sz="1350" b="1">
                 <a:solidFill>
                   <a:srgbClr val="5F6368"/>
@@ -7333,6 +7998,7 @@
           <a:lstStyle xmlns:a="http://schemas.openxmlformats.org/drawingml/2006/main"/>
           <a:p xmlns:a="http://schemas.openxmlformats.org/drawingml/2006/main">
             <a:pPr algn="l">
+              <a:buNone/>
               <a:defRPr sz="3150" b="1">
                 <a:solidFill>
                   <a:srgbClr val="000000"/>
@@ -7389,6 +8055,7 @@
           <a:lstStyle xmlns:a="http://schemas.openxmlformats.org/drawingml/2006/main"/>
           <a:p xmlns:a="http://schemas.openxmlformats.org/drawingml/2006/main">
             <a:pPr algn="l">
+              <a:buNone/>
               <a:defRPr sz="1275" b="0">
                 <a:solidFill>
                   <a:srgbClr val="5F6368"/>
@@ -7480,6 +8147,7 @@
           <a:lstStyle xmlns:a="http://schemas.openxmlformats.org/drawingml/2006/main"/>
           <a:p xmlns:a="http://schemas.openxmlformats.org/drawingml/2006/main">
             <a:pPr algn="l">
+              <a:buNone/>
               <a:defRPr sz="1350" b="1">
                 <a:solidFill>
                   <a:srgbClr val="5F6368"/>
@@ -7536,6 +8204,7 @@
           <a:lstStyle xmlns:a="http://schemas.openxmlformats.org/drawingml/2006/main"/>
           <a:p xmlns:a="http://schemas.openxmlformats.org/drawingml/2006/main">
             <a:pPr algn="l">
+              <a:buNone/>
               <a:defRPr sz="3150" b="1">
                 <a:solidFill>
                   <a:srgbClr val="000000"/>
@@ -7592,6 +8261,7 @@
           <a:lstStyle xmlns:a="http://schemas.openxmlformats.org/drawingml/2006/main"/>
           <a:p xmlns:a="http://schemas.openxmlformats.org/drawingml/2006/main">
             <a:pPr algn="l">
+              <a:buNone/>
               <a:defRPr sz="1275" b="0">
                 <a:solidFill>
                   <a:srgbClr val="5F6368"/>
@@ -7652,14 +8322,14 @@
       </p:sp>
       <p:pic>
         <p:nvPicPr>
-          <p:cNvPr id="42" name=""/>
+          <p:cNvPr id="44" name=""/>
           <p:cNvPicPr>
             <a:picLocks xmlns:a="http://schemas.openxmlformats.org/drawingml/2006/main" noChangeAspect="1"/>
           </p:cNvPicPr>
           <p:nvPr/>
         </p:nvPicPr>
         <p:blipFill>
-          <a:blip xmlns:r="http://schemas.openxmlformats.org/officeDocument/2006/relationships" xmlns:a="http://schemas.openxmlformats.org/drawingml/2006/main" r:embed="R41fd5a0c19b64c47"/>
+          <a:blip xmlns:r="http://schemas.openxmlformats.org/officeDocument/2006/relationships" xmlns:a="http://schemas.openxmlformats.org/drawingml/2006/main" r:embed="R28ed17a96f5849ca"/>
           <a:stretch xmlns:a="http://schemas.openxmlformats.org/drawingml/2006/main"/>
         </p:blipFill>
         <p:spPr>
@@ -7736,6 +8406,7 @@
           <a:lstStyle xmlns:a="http://schemas.openxmlformats.org/drawingml/2006/main"/>
           <a:p xmlns:a="http://schemas.openxmlformats.org/drawingml/2006/main">
             <a:pPr algn="l">
+              <a:buNone/>
               <a:defRPr sz="2925" b="1">
                 <a:solidFill>
                   <a:srgbClr val="000000"/>
@@ -7792,6 +8463,7 @@
           <a:lstStyle xmlns:a="http://schemas.openxmlformats.org/drawingml/2006/main"/>
           <a:p xmlns:a="http://schemas.openxmlformats.org/drawingml/2006/main">
             <a:pPr algn="r">
+              <a:buNone/>
               <a:defRPr sz="1050" b="0">
                 <a:solidFill>
                   <a:srgbClr val="5F6368"/>
@@ -7848,6 +8520,7 @@
           <a:lstStyle xmlns:a="http://schemas.openxmlformats.org/drawingml/2006/main"/>
           <a:p xmlns:a="http://schemas.openxmlformats.org/drawingml/2006/main">
             <a:pPr algn="l">
+              <a:buNone/>
               <a:defRPr sz="1575" b="0">
                 <a:solidFill>
                   <a:srgbClr val="5F6368"/>
@@ -7873,7 +8546,7 @@
       </p:sp>
       <p:graphicFrame>
         <p:nvGraphicFramePr>
-          <p:cNvPr id="19" name="Chart"/>
+          <p:cNvPr id="21" name="Chart"/>
           <p:cNvGraphicFramePr/>
           <p:nvPr/>
         </p:nvGraphicFramePr>
@@ -7883,7 +8556,7 @@
         </p:xfrm>
         <a:graphic xmlns:a="http://schemas.openxmlformats.org/drawingml/2006/main">
           <a:graphicData uri="http://schemas.openxmlformats.org/drawingml/2006/chart">
-            <c:chart xmlns:r="http://schemas.openxmlformats.org/officeDocument/2006/relationships" xmlns:c="http://schemas.openxmlformats.org/drawingml/2006/chart" r:id="R9c858f6e63074613"/>
+            <c:chart xmlns:r="http://schemas.openxmlformats.org/officeDocument/2006/relationships" xmlns:c="http://schemas.openxmlformats.org/drawingml/2006/chart" r:id="R9f8ad9886c9d4045"/>
           </a:graphicData>
         </a:graphic>
       </p:graphicFrame>
@@ -7955,6 +8628,7 @@
           <a:lstStyle xmlns:a="http://schemas.openxmlformats.org/drawingml/2006/main"/>
           <a:p xmlns:a="http://schemas.openxmlformats.org/drawingml/2006/main">
             <a:pPr algn="l">
+              <a:buNone/>
               <a:defRPr sz="2700" b="1">
                 <a:solidFill>
                   <a:srgbClr val="3D8DFF"/>
@@ -8011,6 +8685,7 @@
           <a:lstStyle xmlns:a="http://schemas.openxmlformats.org/drawingml/2006/main"/>
           <a:p xmlns:a="http://schemas.openxmlformats.org/drawingml/2006/main">
             <a:pPr algn="l">
+              <a:buNone/>
               <a:defRPr sz="1650" b="1">
                 <a:solidFill>
                   <a:srgbClr val="000000"/>
@@ -8102,6 +8777,7 @@
           <a:lstStyle xmlns:a="http://schemas.openxmlformats.org/drawingml/2006/main"/>
           <a:p xmlns:a="http://schemas.openxmlformats.org/drawingml/2006/main">
             <a:pPr algn="l">
+              <a:buNone/>
               <a:defRPr sz="2700" b="1">
                 <a:solidFill>
                   <a:srgbClr val="000000"/>
@@ -8158,6 +8834,7 @@
           <a:lstStyle xmlns:a="http://schemas.openxmlformats.org/drawingml/2006/main"/>
           <a:p xmlns:a="http://schemas.openxmlformats.org/drawingml/2006/main">
             <a:pPr algn="l">
+              <a:buNone/>
               <a:defRPr sz="1650" b="1">
                 <a:solidFill>
                   <a:srgbClr val="000000"/>
@@ -8249,6 +8926,7 @@
           <a:lstStyle xmlns:a="http://schemas.openxmlformats.org/drawingml/2006/main"/>
           <a:p xmlns:a="http://schemas.openxmlformats.org/drawingml/2006/main">
             <a:pPr algn="l">
+              <a:buNone/>
               <a:defRPr sz="2700" b="1">
                 <a:solidFill>
                   <a:srgbClr val="000000"/>
@@ -8305,6 +8983,7 @@
           <a:lstStyle xmlns:a="http://schemas.openxmlformats.org/drawingml/2006/main"/>
           <a:p xmlns:a="http://schemas.openxmlformats.org/drawingml/2006/main">
             <a:pPr algn="l">
+              <a:buNone/>
               <a:defRPr sz="1650" b="1">
                 <a:solidFill>
                   <a:srgbClr val="000000"/>
@@ -8396,6 +9075,7 @@
           <a:lstStyle xmlns:a="http://schemas.openxmlformats.org/drawingml/2006/main"/>
           <a:p xmlns:a="http://schemas.openxmlformats.org/drawingml/2006/main">
             <a:pPr algn="ctr">
+              <a:buNone/>
               <a:defRPr sz="1200" b="1">
                 <a:solidFill>
                   <a:srgbClr val="000000"/>
@@ -8450,22 +9130,454 @@
       </p:grpSpPr>
       <p:sp>
         <p:nvSpPr>
+          <p:cNvPr id="24" name="slide-4-title">
+            <a:extLst xmlns:a="http://schemas.openxmlformats.org/drawingml/2006/main">
+              <a:ext uri="{FF2B5EF4-FFF2-40B4-BE49-F238E27FC236}">
+                <a16:creationId xmlns:a16="http://schemas.microsoft.com/office/drawing/2014/main" id="{00C57E6A-E979-4FBC-BB02-642F740EFF14}"/>
+              </a:ext>
+            </a:extLst>
+          </p:cNvPr>
+          <p:cNvSpPr>
+            <a:spLocks xmlns:a="http://schemas.openxmlformats.org/drawingml/2006/main" noGrp="1"/>
+          </p:cNvSpPr>
+          <p:nvPr/>
+        </p:nvSpPr>
+        <p:spPr>
+          <a:xfrm xmlns:a="http://schemas.openxmlformats.org/drawingml/2006/main">
+            <a:off x="400050" y="323850"/>
+            <a:ext cx="10668000" cy="704850"/>
+          </a:xfrm>
+          <a:prstGeom xmlns:a="http://schemas.openxmlformats.org/drawingml/2006/main" prst="rect">
+            <a:avLst/>
+          </a:prstGeom>
+          <a:noFill xmlns:a="http://schemas.openxmlformats.org/drawingml/2006/main"/>
+          <a:ln xmlns:a="http://schemas.openxmlformats.org/drawingml/2006/main" w="0">
+            <a:noFill/>
+            <a:prstDash val="solid"/>
+          </a:ln>
+        </p:spPr>
+        <p:txBody>
+          <a:bodyPr xmlns:a="http://schemas.openxmlformats.org/drawingml/2006/main" anchor="t"/>
+          <a:lstStyle xmlns:a="http://schemas.openxmlformats.org/drawingml/2006/main"/>
+          <a:p xmlns:a="http://schemas.openxmlformats.org/drawingml/2006/main">
+            <a:pPr algn="l">
+              <a:buNone/>
+              <a:defRPr sz="2925" b="1">
+                <a:solidFill>
+                  <a:srgbClr val="000000"/>
+                </a:solidFill>
+                <a:latin typeface="Helvetica Neue"/>
+                <a:ea typeface="Helvetica Neue"/>
+                <a:cs typeface="Helvetica Neue"/>
+              </a:defRPr>
+            </a:pPr>
+            <a:r>
+              <a:rPr sz="2925" b="1">
+                <a:solidFill>
+                  <a:srgbClr val="000000"/>
+                </a:solidFill>
+                <a:latin typeface="Helvetica Neue"/>
+                <a:ea typeface="Helvetica Neue"/>
+                <a:cs typeface="Helvetica Neue"/>
+              </a:rPr>
+              <a:t>Radeon Cloud API support is isolated by design</a:t>
+            </a:r>
+          </a:p>
+        </p:txBody>
+      </p:sp>
+      <p:sp>
+        <p:nvSpPr>
+          <p:cNvPr id="2" name="">
+            <a:extLst xmlns:a="http://schemas.openxmlformats.org/drawingml/2006/main">
+              <a:ext uri="{FF2B5EF4-FFF2-40B4-BE49-F238E27FC236}">
+                <a16:creationId xmlns:a16="http://schemas.microsoft.com/office/drawing/2014/main" id="{C1B3065A-D0C9-49CD-9F7D-AD112A0B8475}"/>
+              </a:ext>
+            </a:extLst>
+          </p:cNvPr>
+          <p:cNvSpPr>
+            <a:spLocks xmlns:a="http://schemas.openxmlformats.org/drawingml/2006/main" noGrp="1"/>
+          </p:cNvSpPr>
+          <p:nvPr/>
+        </p:nvSpPr>
+        <p:spPr>
+          <a:xfrm xmlns:a="http://schemas.openxmlformats.org/drawingml/2006/main">
+            <a:off x="11277600" y="6257925"/>
+            <a:ext cx="523875" cy="247650"/>
+          </a:xfrm>
+          <a:prstGeom xmlns:a="http://schemas.openxmlformats.org/drawingml/2006/main" prst="rect">
+            <a:avLst/>
+          </a:prstGeom>
+          <a:noFill xmlns:a="http://schemas.openxmlformats.org/drawingml/2006/main"/>
+          <a:ln xmlns:a="http://schemas.openxmlformats.org/drawingml/2006/main" w="0">
+            <a:noFill/>
+            <a:prstDash val="solid"/>
+          </a:ln>
+        </p:spPr>
+        <p:txBody>
+          <a:bodyPr xmlns:a="http://schemas.openxmlformats.org/drawingml/2006/main" anchor="b"/>
+          <a:lstStyle xmlns:a="http://schemas.openxmlformats.org/drawingml/2006/main"/>
+          <a:p xmlns:a="http://schemas.openxmlformats.org/drawingml/2006/main">
+            <a:pPr algn="r">
+              <a:buNone/>
+              <a:defRPr sz="1050" b="0">
+                <a:solidFill>
+                  <a:srgbClr val="5F6368"/>
+                </a:solidFill>
+                <a:latin typeface="Helvetica Neue"/>
+                <a:ea typeface="Helvetica Neue"/>
+                <a:cs typeface="Helvetica Neue"/>
+              </a:defRPr>
+            </a:pPr>
+            <a:r>
+              <a:rPr sz="1050" b="0">
+                <a:solidFill>
+                  <a:srgbClr val="5F6368"/>
+                </a:solidFill>
+                <a:latin typeface="Helvetica Neue"/>
+                <a:ea typeface="Helvetica Neue"/>
+                <a:cs typeface="Helvetica Neue"/>
+              </a:rPr>
+              <a:t>9</a:t>
+            </a:r>
+          </a:p>
+        </p:txBody>
+      </p:sp>
+      <p:sp>
+        <p:nvSpPr>
+          <p:cNvPr id="3" name="">
+            <a:extLst xmlns:a="http://schemas.openxmlformats.org/drawingml/2006/main">
+              <a:ext uri="{FF2B5EF4-FFF2-40B4-BE49-F238E27FC236}">
+                <a16:creationId xmlns:a16="http://schemas.microsoft.com/office/drawing/2014/main" id="{8A2CFEC3-5CF6-46EB-8D30-2F0F428A0269}"/>
+              </a:ext>
+            </a:extLst>
+          </p:cNvPr>
+          <p:cNvSpPr>
+            <a:spLocks xmlns:a="http://schemas.openxmlformats.org/drawingml/2006/main" noGrp="1"/>
+          </p:cNvSpPr>
+          <p:nvPr/>
+        </p:nvSpPr>
+        <p:spPr>
+          <a:xfrm xmlns:a="http://schemas.openxmlformats.org/drawingml/2006/main">
+            <a:off x="400050" y="1762125"/>
+            <a:ext cx="1714500" cy="400050"/>
+          </a:xfrm>
+          <a:prstGeom xmlns:a="http://schemas.openxmlformats.org/drawingml/2006/main" prst="rect">
+            <a:avLst/>
+          </a:prstGeom>
+          <a:noFill xmlns:a="http://schemas.openxmlformats.org/drawingml/2006/main"/>
+          <a:ln xmlns:a="http://schemas.openxmlformats.org/drawingml/2006/main" w="0">
+            <a:noFill/>
+            <a:prstDash val="solid"/>
+          </a:ln>
+        </p:spPr>
+        <p:txBody>
+          <a:bodyPr xmlns:a="http://schemas.openxmlformats.org/drawingml/2006/main" anchor="t"/>
+          <a:lstStyle xmlns:a="http://schemas.openxmlformats.org/drawingml/2006/main"/>
+          <a:p xmlns:a="http://schemas.openxmlformats.org/drawingml/2006/main">
+            <a:pPr algn="l">
+              <a:buNone/>
+              <a:defRPr sz="1425" b="1">
+                <a:solidFill>
+                  <a:srgbClr val="3D8DFF"/>
+                </a:solidFill>
+                <a:latin typeface="Helvetica Neue"/>
+                <a:ea typeface="Helvetica Neue"/>
+                <a:cs typeface="Helvetica Neue"/>
+              </a:defRPr>
+            </a:pPr>
+            <a:r>
+              <a:rPr sz="1425" b="1">
+                <a:solidFill>
+                  <a:srgbClr val="3D8DFF"/>
+                </a:solidFill>
+                <a:latin typeface="Helvetica Neue"/>
+                <a:ea typeface="Helvetica Neue"/>
+                <a:cs typeface="Helvetica Neue"/>
+              </a:rPr>
+              <a:t>01</a:t>
+            </a:r>
+          </a:p>
+        </p:txBody>
+      </p:sp>
+      <p:sp>
+        <p:nvSpPr>
+          <p:cNvPr id="4" name="">
+            <a:extLst xmlns:a="http://schemas.openxmlformats.org/drawingml/2006/main">
+              <a:ext uri="{FF2B5EF4-FFF2-40B4-BE49-F238E27FC236}">
+                <a16:creationId xmlns:a16="http://schemas.microsoft.com/office/drawing/2014/main" id="{7FCD1826-B6F0-4B20-ADA7-59C59F583B80}"/>
+              </a:ext>
+            </a:extLst>
+          </p:cNvPr>
+          <p:cNvSpPr>
+            <a:spLocks xmlns:a="http://schemas.openxmlformats.org/drawingml/2006/main" noGrp="1"/>
+          </p:cNvSpPr>
+          <p:nvPr/>
+        </p:nvSpPr>
+        <p:spPr>
+          <a:xfrm xmlns:a="http://schemas.openxmlformats.org/drawingml/2006/main">
+            <a:off x="400050" y="2343150"/>
+            <a:ext cx="1952625" cy="685800"/>
+          </a:xfrm>
+          <a:prstGeom xmlns:a="http://schemas.openxmlformats.org/drawingml/2006/main" prst="rect">
+            <a:avLst/>
+          </a:prstGeom>
+          <a:noFill xmlns:a="http://schemas.openxmlformats.org/drawingml/2006/main"/>
+          <a:ln xmlns:a="http://schemas.openxmlformats.org/drawingml/2006/main" w="0">
+            <a:noFill/>
+            <a:prstDash val="solid"/>
+          </a:ln>
+        </p:spPr>
+        <p:txBody>
+          <a:bodyPr xmlns:a="http://schemas.openxmlformats.org/drawingml/2006/main" anchor="t"/>
+          <a:lstStyle xmlns:a="http://schemas.openxmlformats.org/drawingml/2006/main"/>
+          <a:p xmlns:a="http://schemas.openxmlformats.org/drawingml/2006/main">
+            <a:pPr algn="l">
+              <a:buNone/>
+              <a:defRPr sz="1950" b="1">
+                <a:solidFill>
+                  <a:srgbClr val="000000"/>
+                </a:solidFill>
+                <a:latin typeface="Helvetica Neue"/>
+                <a:ea typeface="Helvetica Neue"/>
+                <a:cs typeface="Helvetica Neue"/>
+              </a:defRPr>
+            </a:pPr>
+            <a:r>
+              <a:rPr sz="1950" b="1">
+                <a:solidFill>
+                  <a:srgbClr val="000000"/>
+                </a:solidFill>
+                <a:latin typeface="Helvetica Neue"/>
+                <a:ea typeface="Helvetica Neue"/>
+                <a:cs typeface="Helvetica Neue"/>
+              </a:rPr>
+              <a:t>Explicit opt-in</a:t>
+            </a:r>
+          </a:p>
+        </p:txBody>
+      </p:sp>
+      <p:sp>
+        <p:nvSpPr>
+          <p:cNvPr id="5" name="">
+            <a:extLst xmlns:a="http://schemas.openxmlformats.org/drawingml/2006/main">
+              <a:ext uri="{FF2B5EF4-FFF2-40B4-BE49-F238E27FC236}">
+                <a16:creationId xmlns:a16="http://schemas.microsoft.com/office/drawing/2014/main" id="{85CC4315-AF3C-4ADD-AE4A-98C9A2755BDE}"/>
+              </a:ext>
+            </a:extLst>
+          </p:cNvPr>
+          <p:cNvSpPr>
+            <a:spLocks xmlns:a="http://schemas.openxmlformats.org/drawingml/2006/main" noGrp="1"/>
+          </p:cNvSpPr>
+          <p:nvPr/>
+        </p:nvSpPr>
+        <p:spPr>
+          <a:xfrm xmlns:a="http://schemas.openxmlformats.org/drawingml/2006/main">
+            <a:off x="400050" y="3257550"/>
+            <a:ext cx="1924050" cy="1619250"/>
+          </a:xfrm>
+          <a:prstGeom xmlns:a="http://schemas.openxmlformats.org/drawingml/2006/main" prst="rect">
+            <a:avLst/>
+          </a:prstGeom>
+          <a:noFill xmlns:a="http://schemas.openxmlformats.org/drawingml/2006/main"/>
+          <a:ln xmlns:a="http://schemas.openxmlformats.org/drawingml/2006/main" w="0">
+            <a:noFill/>
+            <a:prstDash val="solid"/>
+          </a:ln>
+        </p:spPr>
+        <p:txBody>
+          <a:bodyPr xmlns:a="http://schemas.openxmlformats.org/drawingml/2006/main" anchor="t"/>
+          <a:lstStyle xmlns:a="http://schemas.openxmlformats.org/drawingml/2006/main"/>
+          <a:p xmlns:a="http://schemas.openxmlformats.org/drawingml/2006/main">
+            <a:pPr algn="l">
+              <a:buNone/>
+              <a:defRPr sz="1350" b="0">
+                <a:solidFill>
+                  <a:srgbClr val="5F6368"/>
+                </a:solidFill>
+                <a:latin typeface="Helvetica Neue"/>
+                <a:ea typeface="Helvetica Neue"/>
+                <a:cs typeface="Helvetica Neue"/>
+              </a:defRPr>
+            </a:pPr>
+            <a:r>
+              <a:rPr sz="1350" b="0">
+                <a:solidFill>
+                  <a:srgbClr val="5F6368"/>
+                </a:solidFill>
+                <a:latin typeface="Helvetica Neue"/>
+                <a:ea typeface="Helvetica Neue"/>
+                <a:cs typeface="Helvetica Neue"/>
+              </a:rPr>
+              <a:t>Off by default; radeon_cloud_free requires dedicated bonus mode.</a:t>
+            </a:r>
+          </a:p>
+        </p:txBody>
+      </p:sp>
+      <p:sp>
+        <p:nvSpPr>
+          <p:cNvPr id="6" name="">
+            <a:extLst xmlns:a="http://schemas.openxmlformats.org/drawingml/2006/main">
+              <a:ext uri="{FF2B5EF4-FFF2-40B4-BE49-F238E27FC236}">
+                <a16:creationId xmlns:a16="http://schemas.microsoft.com/office/drawing/2014/main" id="{78AD1360-3ACF-4D6A-A1A7-EF5BE6DFE7DA}"/>
+              </a:ext>
+            </a:extLst>
+          </p:cNvPr>
+          <p:cNvSpPr>
+            <a:spLocks xmlns:a="http://schemas.openxmlformats.org/drawingml/2006/main" noGrp="1"/>
+          </p:cNvSpPr>
+          <p:nvPr/>
+        </p:nvSpPr>
+        <p:spPr>
+          <a:xfrm xmlns:a="http://schemas.openxmlformats.org/drawingml/2006/main">
+            <a:off x="2533650" y="1781175"/>
+            <a:ext cx="9525" cy="3562350"/>
+          </a:xfrm>
+          <a:prstGeom xmlns:a="http://schemas.openxmlformats.org/drawingml/2006/main" prst="rect">
+            <a:avLst/>
+          </a:prstGeom>
+          <a:solidFill xmlns:a="http://schemas.openxmlformats.org/drawingml/2006/main">
+            <a:srgbClr val="B8BCC4"/>
+          </a:solidFill>
+          <a:ln xmlns:a="http://schemas.openxmlformats.org/drawingml/2006/main" w="0">
+            <a:solidFill>
+              <a:srgbClr val="B8BCC4"/>
+            </a:solidFill>
+            <a:prstDash val="solid"/>
+          </a:ln>
+        </p:spPr>
+      </p:sp>
+      <p:sp>
+        <p:nvSpPr>
+          <p:cNvPr id="7" name="">
+            <a:extLst xmlns:a="http://schemas.openxmlformats.org/drawingml/2006/main">
+              <a:ext uri="{FF2B5EF4-FFF2-40B4-BE49-F238E27FC236}">
+                <a16:creationId xmlns:a16="http://schemas.microsoft.com/office/drawing/2014/main" id="{F4821B5E-7575-4958-831F-D2F92D769A5D}"/>
+              </a:ext>
+            </a:extLst>
+          </p:cNvPr>
+          <p:cNvSpPr>
+            <a:spLocks xmlns:a="http://schemas.openxmlformats.org/drawingml/2006/main" noGrp="1"/>
+          </p:cNvSpPr>
+          <p:nvPr/>
+        </p:nvSpPr>
+        <p:spPr>
+          <a:xfrm xmlns:a="http://schemas.openxmlformats.org/drawingml/2006/main">
+            <a:off x="2724150" y="1762125"/>
+            <a:ext cx="1714500" cy="400050"/>
+          </a:xfrm>
+          <a:prstGeom xmlns:a="http://schemas.openxmlformats.org/drawingml/2006/main" prst="rect">
+            <a:avLst/>
+          </a:prstGeom>
+          <a:noFill xmlns:a="http://schemas.openxmlformats.org/drawingml/2006/main"/>
+          <a:ln xmlns:a="http://schemas.openxmlformats.org/drawingml/2006/main" w="0">
+            <a:noFill/>
+            <a:prstDash val="solid"/>
+          </a:ln>
+        </p:spPr>
+        <p:txBody>
+          <a:bodyPr xmlns:a="http://schemas.openxmlformats.org/drawingml/2006/main" anchor="t"/>
+          <a:lstStyle xmlns:a="http://schemas.openxmlformats.org/drawingml/2006/main"/>
+          <a:p xmlns:a="http://schemas.openxmlformats.org/drawingml/2006/main">
+            <a:pPr algn="l">
+              <a:buNone/>
+              <a:defRPr sz="1425" b="1">
+                <a:solidFill>
+                  <a:srgbClr val="3D8DFF"/>
+                </a:solidFill>
+                <a:latin typeface="Helvetica Neue"/>
+                <a:ea typeface="Helvetica Neue"/>
+                <a:cs typeface="Helvetica Neue"/>
+              </a:defRPr>
+            </a:pPr>
+            <a:r>
+              <a:rPr sz="1425" b="1">
+                <a:solidFill>
+                  <a:srgbClr val="3D8DFF"/>
+                </a:solidFill>
+                <a:latin typeface="Helvetica Neue"/>
+                <a:ea typeface="Helvetica Neue"/>
+                <a:cs typeface="Helvetica Neue"/>
+              </a:rPr>
+              <a:t>02</a:t>
+            </a:r>
+          </a:p>
+        </p:txBody>
+      </p:sp>
+      <p:sp>
+        <p:nvSpPr>
+          <p:cNvPr id="8" name="">
+            <a:extLst xmlns:a="http://schemas.openxmlformats.org/drawingml/2006/main">
+              <a:ext uri="{FF2B5EF4-FFF2-40B4-BE49-F238E27FC236}">
+                <a16:creationId xmlns:a16="http://schemas.microsoft.com/office/drawing/2014/main" id="{DAF6396F-F13C-4190-89CC-F30358B49273}"/>
+              </a:ext>
+            </a:extLst>
+          </p:cNvPr>
+          <p:cNvSpPr>
+            <a:spLocks xmlns:a="http://schemas.openxmlformats.org/drawingml/2006/main" noGrp="1"/>
+          </p:cNvSpPr>
+          <p:nvPr/>
+        </p:nvSpPr>
+        <p:spPr>
+          <a:xfrm xmlns:a="http://schemas.openxmlformats.org/drawingml/2006/main">
+            <a:off x="2724150" y="2343150"/>
+            <a:ext cx="1952625" cy="685800"/>
+          </a:xfrm>
+          <a:prstGeom xmlns:a="http://schemas.openxmlformats.org/drawingml/2006/main" prst="rect">
+            <a:avLst/>
+          </a:prstGeom>
+          <a:noFill xmlns:a="http://schemas.openxmlformats.org/drawingml/2006/main"/>
+          <a:ln xmlns:a="http://schemas.openxmlformats.org/drawingml/2006/main" w="0">
+            <a:noFill/>
+            <a:prstDash val="solid"/>
+          </a:ln>
+        </p:spPr>
+        <p:txBody>
+          <a:bodyPr xmlns:a="http://schemas.openxmlformats.org/drawingml/2006/main" anchor="t"/>
+          <a:lstStyle xmlns:a="http://schemas.openxmlformats.org/drawingml/2006/main"/>
+          <a:p xmlns:a="http://schemas.openxmlformats.org/drawingml/2006/main">
+            <a:pPr algn="l">
+              <a:buNone/>
+              <a:defRPr sz="1950" b="1">
+                <a:solidFill>
+                  <a:srgbClr val="000000"/>
+                </a:solidFill>
+                <a:latin typeface="Helvetica Neue"/>
+                <a:ea typeface="Helvetica Neue"/>
+                <a:cs typeface="Helvetica Neue"/>
+              </a:defRPr>
+            </a:pPr>
+            <a:r>
+              <a:rPr sz="1950" b="1">
+                <a:solidFill>
+                  <a:srgbClr val="000000"/>
+                </a:solidFill>
+                <a:latin typeface="Helvetica Neue"/>
+                <a:ea typeface="Helvetica Neue"/>
+                <a:cs typeface="Helvetica Neue"/>
+              </a:rPr>
+              <a:t>Official API</a:t>
+            </a:r>
+          </a:p>
+        </p:txBody>
+      </p:sp>
+      <p:sp>
+        <p:nvSpPr>
           <p:cNvPr id="9" name="">
             <a:extLst xmlns:a="http://schemas.openxmlformats.org/drawingml/2006/main">
               <a:ext uri="{FF2B5EF4-FFF2-40B4-BE49-F238E27FC236}">
-                <a16:creationId xmlns:a16="http://schemas.microsoft.com/office/drawing/2014/main" id="{34AE98F7-7BF8-42CA-AD69-6BBE6B317081}"/>
-              </a:ext>
-            </a:extLst>
-          </p:cNvPr>
-          <p:cNvSpPr>
-            <a:spLocks xmlns:a="http://schemas.openxmlformats.org/drawingml/2006/main" noGrp="1"/>
-          </p:cNvSpPr>
-          <p:nvPr/>
-        </p:nvSpPr>
-        <p:spPr>
-          <a:xfrm xmlns:a="http://schemas.openxmlformats.org/drawingml/2006/main">
-            <a:off x="400050" y="400050"/>
-            <a:ext cx="3429000" cy="323850"/>
+                <a16:creationId xmlns:a16="http://schemas.microsoft.com/office/drawing/2014/main" id="{E4155D09-CC64-4D33-B26D-E4B5017D7012}"/>
+              </a:ext>
+            </a:extLst>
+          </p:cNvPr>
+          <p:cNvSpPr>
+            <a:spLocks xmlns:a="http://schemas.openxmlformats.org/drawingml/2006/main" noGrp="1"/>
+          </p:cNvSpPr>
+          <p:nvPr/>
+        </p:nvSpPr>
+        <p:spPr>
+          <a:xfrm xmlns:a="http://schemas.openxmlformats.org/drawingml/2006/main">
+            <a:off x="2724150" y="3257550"/>
+            <a:ext cx="1924050" cy="1619250"/>
           </a:xfrm>
           <a:prstGeom xmlns:a="http://schemas.openxmlformats.org/drawingml/2006/main" prst="rect">
             <a:avLst/>
@@ -8481,7 +9593,98 @@
           <a:lstStyle xmlns:a="http://schemas.openxmlformats.org/drawingml/2006/main"/>
           <a:p xmlns:a="http://schemas.openxmlformats.org/drawingml/2006/main">
             <a:pPr algn="l">
-              <a:defRPr sz="1350" b="1">
+              <a:buNone/>
+              <a:defRPr sz="1350" b="0">
+                <a:solidFill>
+                  <a:srgbClr val="5F6368"/>
+                </a:solidFill>
+                <a:latin typeface="Helvetica Neue"/>
+                <a:ea typeface="Helvetica Neue"/>
+                <a:cs typeface="Helvetica Neue"/>
+              </a:defRPr>
+            </a:pPr>
+            <a:r>
+              <a:rPr sz="1350" b="0">
+                <a:solidFill>
+                  <a:srgbClr val="5F6368"/>
+                </a:solidFill>
+                <a:latin typeface="Helvetica Neue"/>
+                <a:ea typeface="Helvetica Neue"/>
+                <a:cs typeface="Helvetica Neue"/>
+              </a:rPr>
+              <a:t>Qwen3.6-35B-A3B through AMD Radeon Cloud Public Free Model API.</a:t>
+            </a:r>
+          </a:p>
+        </p:txBody>
+      </p:sp>
+      <p:sp>
+        <p:nvSpPr>
+          <p:cNvPr id="10" name="">
+            <a:extLst xmlns:a="http://schemas.openxmlformats.org/drawingml/2006/main">
+              <a:ext uri="{FF2B5EF4-FFF2-40B4-BE49-F238E27FC236}">
+                <a16:creationId xmlns:a16="http://schemas.microsoft.com/office/drawing/2014/main" id="{9428D28C-5ECF-40F3-9E67-4A97FAE80E61}"/>
+              </a:ext>
+            </a:extLst>
+          </p:cNvPr>
+          <p:cNvSpPr>
+            <a:spLocks xmlns:a="http://schemas.openxmlformats.org/drawingml/2006/main" noGrp="1"/>
+          </p:cNvSpPr>
+          <p:nvPr/>
+        </p:nvSpPr>
+        <p:spPr>
+          <a:xfrm xmlns:a="http://schemas.openxmlformats.org/drawingml/2006/main">
+            <a:off x="4857750" y="1781175"/>
+            <a:ext cx="9525" cy="3562350"/>
+          </a:xfrm>
+          <a:prstGeom xmlns:a="http://schemas.openxmlformats.org/drawingml/2006/main" prst="rect">
+            <a:avLst/>
+          </a:prstGeom>
+          <a:solidFill xmlns:a="http://schemas.openxmlformats.org/drawingml/2006/main">
+            <a:srgbClr val="B8BCC4"/>
+          </a:solidFill>
+          <a:ln xmlns:a="http://schemas.openxmlformats.org/drawingml/2006/main" w="0">
+            <a:solidFill>
+              <a:srgbClr val="B8BCC4"/>
+            </a:solidFill>
+            <a:prstDash val="solid"/>
+          </a:ln>
+        </p:spPr>
+      </p:sp>
+      <p:sp>
+        <p:nvSpPr>
+          <p:cNvPr id="11" name="">
+            <a:extLst xmlns:a="http://schemas.openxmlformats.org/drawingml/2006/main">
+              <a:ext uri="{FF2B5EF4-FFF2-40B4-BE49-F238E27FC236}">
+                <a16:creationId xmlns:a16="http://schemas.microsoft.com/office/drawing/2014/main" id="{5D800D92-8F73-482A-8E4D-B7D8F50BC158}"/>
+              </a:ext>
+            </a:extLst>
+          </p:cNvPr>
+          <p:cNvSpPr>
+            <a:spLocks xmlns:a="http://schemas.openxmlformats.org/drawingml/2006/main" noGrp="1"/>
+          </p:cNvSpPr>
+          <p:nvPr/>
+        </p:nvSpPr>
+        <p:spPr>
+          <a:xfrm xmlns:a="http://schemas.openxmlformats.org/drawingml/2006/main">
+            <a:off x="5048250" y="1762125"/>
+            <a:ext cx="1714500" cy="400050"/>
+          </a:xfrm>
+          <a:prstGeom xmlns:a="http://schemas.openxmlformats.org/drawingml/2006/main" prst="rect">
+            <a:avLst/>
+          </a:prstGeom>
+          <a:noFill xmlns:a="http://schemas.openxmlformats.org/drawingml/2006/main"/>
+          <a:ln xmlns:a="http://schemas.openxmlformats.org/drawingml/2006/main" w="0">
+            <a:noFill/>
+            <a:prstDash val="solid"/>
+          </a:ln>
+        </p:spPr>
+        <p:txBody>
+          <a:bodyPr xmlns:a="http://schemas.openxmlformats.org/drawingml/2006/main" anchor="t"/>
+          <a:lstStyle xmlns:a="http://schemas.openxmlformats.org/drawingml/2006/main"/>
+          <a:p xmlns:a="http://schemas.openxmlformats.org/drawingml/2006/main">
+            <a:pPr algn="l">
+              <a:buNone/>
+              <a:defRPr sz="1425" b="1">
                 <a:solidFill>
                   <a:srgbClr val="3D8DFF"/>
                 </a:solidFill>
@@ -8491,7 +9694,7 @@
               </a:defRPr>
             </a:pPr>
             <a:r>
-              <a:rPr sz="1350" b="1">
+              <a:rPr sz="1425" b="1">
                 <a:solidFill>
                   <a:srgbClr val="3D8DFF"/>
                 </a:solidFill>
@@ -8499,45 +9702,46 @@
                 <a:ea typeface="Helvetica Neue"/>
                 <a:cs typeface="Helvetica Neue"/>
               </a:rPr>
-              <a:t>TRACK 2 · RADEONHOTEL</a:t>
-            </a:r>
-          </a:p>
-        </p:txBody>
-      </p:sp>
-      <p:sp>
-        <p:nvSpPr>
-          <p:cNvPr id="2" name="">
-            <a:extLst xmlns:a="http://schemas.openxmlformats.org/drawingml/2006/main">
-              <a:ext uri="{FF2B5EF4-FFF2-40B4-BE49-F238E27FC236}">
-                <a16:creationId xmlns:a16="http://schemas.microsoft.com/office/drawing/2014/main" id="{577713F9-EDC5-4976-904C-CF0CE4F86238}"/>
-              </a:ext>
-            </a:extLst>
-          </p:cNvPr>
-          <p:cNvSpPr>
-            <a:spLocks xmlns:a="http://schemas.openxmlformats.org/drawingml/2006/main" noGrp="1"/>
-          </p:cNvSpPr>
-          <p:nvPr/>
-        </p:nvSpPr>
-        <p:spPr>
-          <a:xfrm xmlns:a="http://schemas.openxmlformats.org/drawingml/2006/main">
-            <a:off x="400050" y="1638300"/>
-            <a:ext cx="9620250" cy="2000250"/>
-          </a:xfrm>
-          <a:prstGeom xmlns:a="http://schemas.openxmlformats.org/drawingml/2006/main" prst="rect">
-            <a:avLst/>
-          </a:prstGeom>
-          <a:noFill xmlns:a="http://schemas.openxmlformats.org/drawingml/2006/main"/>
-          <a:ln xmlns:a="http://schemas.openxmlformats.org/drawingml/2006/main" w="0">
-            <a:noFill/>
-            <a:prstDash val="solid"/>
-          </a:ln>
-        </p:spPr>
-        <p:txBody>
-          <a:bodyPr xmlns:a="http://schemas.openxmlformats.org/drawingml/2006/main" anchor="b"/>
+              <a:t>03</a:t>
+            </a:r>
+          </a:p>
+        </p:txBody>
+      </p:sp>
+      <p:sp>
+        <p:nvSpPr>
+          <p:cNvPr id="12" name="">
+            <a:extLst xmlns:a="http://schemas.openxmlformats.org/drawingml/2006/main">
+              <a:ext uri="{FF2B5EF4-FFF2-40B4-BE49-F238E27FC236}">
+                <a16:creationId xmlns:a16="http://schemas.microsoft.com/office/drawing/2014/main" id="{563B32D3-3362-4F26-B05D-D8D76BCDBF43}"/>
+              </a:ext>
+            </a:extLst>
+          </p:cNvPr>
+          <p:cNvSpPr>
+            <a:spLocks xmlns:a="http://schemas.openxmlformats.org/drawingml/2006/main" noGrp="1"/>
+          </p:cNvSpPr>
+          <p:nvPr/>
+        </p:nvSpPr>
+        <p:spPr>
+          <a:xfrm xmlns:a="http://schemas.openxmlformats.org/drawingml/2006/main">
+            <a:off x="5048250" y="2343150"/>
+            <a:ext cx="1952625" cy="685800"/>
+          </a:xfrm>
+          <a:prstGeom xmlns:a="http://schemas.openxmlformats.org/drawingml/2006/main" prst="rect">
+            <a:avLst/>
+          </a:prstGeom>
+          <a:noFill xmlns:a="http://schemas.openxmlformats.org/drawingml/2006/main"/>
+          <a:ln xmlns:a="http://schemas.openxmlformats.org/drawingml/2006/main" w="0">
+            <a:noFill/>
+            <a:prstDash val="solid"/>
+          </a:ln>
+        </p:spPr>
+        <p:txBody>
+          <a:bodyPr xmlns:a="http://schemas.openxmlformats.org/drawingml/2006/main" anchor="t"/>
           <a:lstStyle xmlns:a="http://schemas.openxmlformats.org/drawingml/2006/main"/>
           <a:p xmlns:a="http://schemas.openxmlformats.org/drawingml/2006/main">
             <a:pPr algn="l">
-              <a:defRPr sz="4650" b="1">
+              <a:buNone/>
+              <a:defRPr sz="1950" b="1">
                 <a:solidFill>
                   <a:srgbClr val="000000"/>
                 </a:solidFill>
@@ -8547,7 +9751,7 @@
               </a:defRPr>
             </a:pPr>
             <a:r>
-              <a:rPr sz="4650" b="1">
+              <a:rPr sz="1950" b="1">
                 <a:solidFill>
                   <a:srgbClr val="000000"/>
                 </a:solidFill>
@@ -8555,39 +9759,96 @@
                 <a:ea typeface="Helvetica Neue"/>
                 <a:cs typeface="Helvetica Neue"/>
               </a:rPr>
-              <a:t>A private journey agent judges can verify end to end</a:t>
-            </a:r>
-          </a:p>
-        </p:txBody>
-      </p:sp>
-      <p:sp>
-        <p:nvSpPr>
-          <p:cNvPr id="3" name="">
-            <a:extLst xmlns:a="http://schemas.openxmlformats.org/drawingml/2006/main">
-              <a:ext uri="{FF2B5EF4-FFF2-40B4-BE49-F238E27FC236}">
-                <a16:creationId xmlns:a16="http://schemas.microsoft.com/office/drawing/2014/main" id="{BDC4202C-0065-4556-A3DE-2BB9C475E604}"/>
-              </a:ext>
-            </a:extLst>
-          </p:cNvPr>
-          <p:cNvSpPr>
-            <a:spLocks xmlns:a="http://schemas.openxmlformats.org/drawingml/2006/main" noGrp="1"/>
-          </p:cNvSpPr>
-          <p:nvPr/>
-        </p:nvSpPr>
-        <p:spPr>
-          <a:xfrm xmlns:a="http://schemas.openxmlformats.org/drawingml/2006/main">
-            <a:off x="400050" y="4171950"/>
-            <a:ext cx="11401425" cy="28575"/>
+              <a:t>Other optimization</a:t>
+            </a:r>
+          </a:p>
+        </p:txBody>
+      </p:sp>
+      <p:sp>
+        <p:nvSpPr>
+          <p:cNvPr id="13" name="">
+            <a:extLst xmlns:a="http://schemas.openxmlformats.org/drawingml/2006/main">
+              <a:ext uri="{FF2B5EF4-FFF2-40B4-BE49-F238E27FC236}">
+                <a16:creationId xmlns:a16="http://schemas.microsoft.com/office/drawing/2014/main" id="{894C7674-D6B2-4B8E-871E-E2BDAB3AEEA9}"/>
+              </a:ext>
+            </a:extLst>
+          </p:cNvPr>
+          <p:cNvSpPr>
+            <a:spLocks xmlns:a="http://schemas.openxmlformats.org/drawingml/2006/main" noGrp="1"/>
+          </p:cNvSpPr>
+          <p:nvPr/>
+        </p:nvSpPr>
+        <p:spPr>
+          <a:xfrm xmlns:a="http://schemas.openxmlformats.org/drawingml/2006/main">
+            <a:off x="5048250" y="3257550"/>
+            <a:ext cx="1924050" cy="1619250"/>
+          </a:xfrm>
+          <a:prstGeom xmlns:a="http://schemas.openxmlformats.org/drawingml/2006/main" prst="rect">
+            <a:avLst/>
+          </a:prstGeom>
+          <a:noFill xmlns:a="http://schemas.openxmlformats.org/drawingml/2006/main"/>
+          <a:ln xmlns:a="http://schemas.openxmlformats.org/drawingml/2006/main" w="0">
+            <a:noFill/>
+            <a:prstDash val="solid"/>
+          </a:ln>
+        </p:spPr>
+        <p:txBody>
+          <a:bodyPr xmlns:a="http://schemas.openxmlformats.org/drawingml/2006/main" anchor="t"/>
+          <a:lstStyle xmlns:a="http://schemas.openxmlformats.org/drawingml/2006/main"/>
+          <a:p xmlns:a="http://schemas.openxmlformats.org/drawingml/2006/main">
+            <a:pPr algn="l">
+              <a:buNone/>
+              <a:defRPr sz="1350" b="0">
+                <a:solidFill>
+                  <a:srgbClr val="5F6368"/>
+                </a:solidFill>
+                <a:latin typeface="Helvetica Neue"/>
+                <a:ea typeface="Helvetica Neue"/>
+                <a:cs typeface="Helvetica Neue"/>
+              </a:defRPr>
+            </a:pPr>
+            <a:r>
+              <a:rPr sz="1350" b="0">
+                <a:solidFill>
+                  <a:srgbClr val="5F6368"/>
+                </a:solidFill>
+                <a:latin typeface="Helvetica Neue"/>
+                <a:ea typeface="Helvetica Neue"/>
+                <a:cs typeface="Helvetica Neue"/>
+              </a:rPr>
+              <a:t>Fuse plan generation and evidence selection into one bounded model call.</a:t>
+            </a:r>
+          </a:p>
+        </p:txBody>
+      </p:sp>
+      <p:sp>
+        <p:nvSpPr>
+          <p:cNvPr id="14" name="">
+            <a:extLst xmlns:a="http://schemas.openxmlformats.org/drawingml/2006/main">
+              <a:ext uri="{FF2B5EF4-FFF2-40B4-BE49-F238E27FC236}">
+                <a16:creationId xmlns:a16="http://schemas.microsoft.com/office/drawing/2014/main" id="{26C2295F-B3F5-4FC2-B3FF-362C0A04F011}"/>
+              </a:ext>
+            </a:extLst>
+          </p:cNvPr>
+          <p:cNvSpPr>
+            <a:spLocks xmlns:a="http://schemas.openxmlformats.org/drawingml/2006/main" noGrp="1"/>
+          </p:cNvSpPr>
+          <p:nvPr/>
+        </p:nvSpPr>
+        <p:spPr>
+          <a:xfrm xmlns:a="http://schemas.openxmlformats.org/drawingml/2006/main">
+            <a:off x="7181850" y="1781175"/>
+            <a:ext cx="9525" cy="3562350"/>
           </a:xfrm>
           <a:prstGeom xmlns:a="http://schemas.openxmlformats.org/drawingml/2006/main" prst="rect">
             <a:avLst/>
           </a:prstGeom>
           <a:solidFill xmlns:a="http://schemas.openxmlformats.org/drawingml/2006/main">
-            <a:srgbClr val="3D8DFF"/>
+            <a:srgbClr val="B8BCC4"/>
           </a:solidFill>
           <a:ln xmlns:a="http://schemas.openxmlformats.org/drawingml/2006/main" w="0">
             <a:solidFill>
-              <a:srgbClr val="3D8DFF"/>
+              <a:srgbClr val="B8BCC4"/>
             </a:solidFill>
             <a:prstDash val="solid"/>
           </a:ln>
@@ -8595,22 +9856,22 @@
       </p:sp>
       <p:sp>
         <p:nvSpPr>
-          <p:cNvPr id="4" name="">
-            <a:extLst xmlns:a="http://schemas.openxmlformats.org/drawingml/2006/main">
-              <a:ext uri="{FF2B5EF4-FFF2-40B4-BE49-F238E27FC236}">
-                <a16:creationId xmlns:a16="http://schemas.microsoft.com/office/drawing/2014/main" id="{76C16EE5-9BCD-470B-BCD9-C7A5E4804AAA}"/>
-              </a:ext>
-            </a:extLst>
-          </p:cNvPr>
-          <p:cNvSpPr>
-            <a:spLocks xmlns:a="http://schemas.openxmlformats.org/drawingml/2006/main" noGrp="1"/>
-          </p:cNvSpPr>
-          <p:nvPr/>
-        </p:nvSpPr>
-        <p:spPr>
-          <a:xfrm xmlns:a="http://schemas.openxmlformats.org/drawingml/2006/main">
-            <a:off x="400050" y="4686300"/>
-            <a:ext cx="1809750" cy="266700"/>
+          <p:cNvPr id="15" name="">
+            <a:extLst xmlns:a="http://schemas.openxmlformats.org/drawingml/2006/main">
+              <a:ext uri="{FF2B5EF4-FFF2-40B4-BE49-F238E27FC236}">
+                <a16:creationId xmlns:a16="http://schemas.microsoft.com/office/drawing/2014/main" id="{3AA3F2B2-4CD7-4257-BD7A-8843AFAC005F}"/>
+              </a:ext>
+            </a:extLst>
+          </p:cNvPr>
+          <p:cNvSpPr>
+            <a:spLocks xmlns:a="http://schemas.openxmlformats.org/drawingml/2006/main" noGrp="1"/>
+          </p:cNvSpPr>
+          <p:nvPr/>
+        </p:nvSpPr>
+        <p:spPr>
+          <a:xfrm xmlns:a="http://schemas.openxmlformats.org/drawingml/2006/main">
+            <a:off x="7372350" y="1762125"/>
+            <a:ext cx="1714500" cy="400050"/>
           </a:xfrm>
           <a:prstGeom xmlns:a="http://schemas.openxmlformats.org/drawingml/2006/main" prst="rect">
             <a:avLst/>
@@ -8626,7 +9887,122 @@
           <a:lstStyle xmlns:a="http://schemas.openxmlformats.org/drawingml/2006/main"/>
           <a:p xmlns:a="http://schemas.openxmlformats.org/drawingml/2006/main">
             <a:pPr algn="l">
-              <a:defRPr sz="1350" b="1">
+              <a:buNone/>
+              <a:defRPr sz="1425" b="1">
+                <a:solidFill>
+                  <a:srgbClr val="3D8DFF"/>
+                </a:solidFill>
+                <a:latin typeface="Helvetica Neue"/>
+                <a:ea typeface="Helvetica Neue"/>
+                <a:cs typeface="Helvetica Neue"/>
+              </a:defRPr>
+            </a:pPr>
+            <a:r>
+              <a:rPr sz="1425" b="1">
+                <a:solidFill>
+                  <a:srgbClr val="3D8DFF"/>
+                </a:solidFill>
+                <a:latin typeface="Helvetica Neue"/>
+                <a:ea typeface="Helvetica Neue"/>
+                <a:cs typeface="Helvetica Neue"/>
+              </a:rPr>
+              <a:t>04</a:t>
+            </a:r>
+          </a:p>
+        </p:txBody>
+      </p:sp>
+      <p:sp>
+        <p:nvSpPr>
+          <p:cNvPr id="16" name="">
+            <a:extLst xmlns:a="http://schemas.openxmlformats.org/drawingml/2006/main">
+              <a:ext uri="{FF2B5EF4-FFF2-40B4-BE49-F238E27FC236}">
+                <a16:creationId xmlns:a16="http://schemas.microsoft.com/office/drawing/2014/main" id="{6BCE6A8E-FD38-453D-A1F6-AE605A0AAE8A}"/>
+              </a:ext>
+            </a:extLst>
+          </p:cNvPr>
+          <p:cNvSpPr>
+            <a:spLocks xmlns:a="http://schemas.openxmlformats.org/drawingml/2006/main" noGrp="1"/>
+          </p:cNvSpPr>
+          <p:nvPr/>
+        </p:nvSpPr>
+        <p:spPr>
+          <a:xfrm xmlns:a="http://schemas.openxmlformats.org/drawingml/2006/main">
+            <a:off x="7372350" y="2343150"/>
+            <a:ext cx="1952625" cy="685800"/>
+          </a:xfrm>
+          <a:prstGeom xmlns:a="http://schemas.openxmlformats.org/drawingml/2006/main" prst="rect">
+            <a:avLst/>
+          </a:prstGeom>
+          <a:noFill xmlns:a="http://schemas.openxmlformats.org/drawingml/2006/main"/>
+          <a:ln xmlns:a="http://schemas.openxmlformats.org/drawingml/2006/main" w="0">
+            <a:noFill/>
+            <a:prstDash val="solid"/>
+          </a:ln>
+        </p:spPr>
+        <p:txBody>
+          <a:bodyPr xmlns:a="http://schemas.openxmlformats.org/drawingml/2006/main" anchor="t"/>
+          <a:lstStyle xmlns:a="http://schemas.openxmlformats.org/drawingml/2006/main"/>
+          <a:p xmlns:a="http://schemas.openxmlformats.org/drawingml/2006/main">
+            <a:pPr algn="l">
+              <a:buNone/>
+              <a:defRPr sz="1950" b="1">
+                <a:solidFill>
+                  <a:srgbClr val="000000"/>
+                </a:solidFill>
+                <a:latin typeface="Helvetica Neue"/>
+                <a:ea typeface="Helvetica Neue"/>
+                <a:cs typeface="Helvetica Neue"/>
+              </a:defRPr>
+            </a:pPr>
+            <a:r>
+              <a:rPr sz="1950" b="1">
+                <a:solidFill>
+                  <a:srgbClr val="000000"/>
+                </a:solidFill>
+                <a:latin typeface="Helvetica Neue"/>
+                <a:ea typeface="Helvetica Neue"/>
+                <a:cs typeface="Helvetica Neue"/>
+              </a:rPr>
+              <a:t>Fail closed</a:t>
+            </a:r>
+          </a:p>
+        </p:txBody>
+      </p:sp>
+      <p:sp>
+        <p:nvSpPr>
+          <p:cNvPr id="17" name="">
+            <a:extLst xmlns:a="http://schemas.openxmlformats.org/drawingml/2006/main">
+              <a:ext uri="{FF2B5EF4-FFF2-40B4-BE49-F238E27FC236}">
+                <a16:creationId xmlns:a16="http://schemas.microsoft.com/office/drawing/2014/main" id="{C25E889C-A34A-4BFE-B199-DCF225066849}"/>
+              </a:ext>
+            </a:extLst>
+          </p:cNvPr>
+          <p:cNvSpPr>
+            <a:spLocks xmlns:a="http://schemas.openxmlformats.org/drawingml/2006/main" noGrp="1"/>
+          </p:cNvSpPr>
+          <p:nvPr/>
+        </p:nvSpPr>
+        <p:spPr>
+          <a:xfrm xmlns:a="http://schemas.openxmlformats.org/drawingml/2006/main">
+            <a:off x="7372350" y="3257550"/>
+            <a:ext cx="1924050" cy="1619250"/>
+          </a:xfrm>
+          <a:prstGeom xmlns:a="http://schemas.openxmlformats.org/drawingml/2006/main" prst="rect">
+            <a:avLst/>
+          </a:prstGeom>
+          <a:noFill xmlns:a="http://schemas.openxmlformats.org/drawingml/2006/main"/>
+          <a:ln xmlns:a="http://schemas.openxmlformats.org/drawingml/2006/main" w="0">
+            <a:noFill/>
+            <a:prstDash val="solid"/>
+          </a:ln>
+        </p:spPr>
+        <p:txBody>
+          <a:bodyPr xmlns:a="http://schemas.openxmlformats.org/drawingml/2006/main" anchor="t"/>
+          <a:lstStyle xmlns:a="http://schemas.openxmlformats.org/drawingml/2006/main"/>
+          <a:p xmlns:a="http://schemas.openxmlformats.org/drawingml/2006/main">
+            <a:pPr algn="l">
+              <a:buNone/>
+              <a:defRPr sz="1350" b="0">
                 <a:solidFill>
                   <a:srgbClr val="5F6368"/>
                 </a:solidFill>
@@ -8636,7 +10012,7 @@
               </a:defRPr>
             </a:pPr>
             <a:r>
-              <a:rPr sz="1350" b="1">
+              <a:rPr sz="1350" b="0">
                 <a:solidFill>
                   <a:srgbClr val="5F6368"/>
                 </a:solidFill>
@@ -8644,29 +10020,62 @@
                 <a:ea typeface="Helvetica Neue"/>
                 <a:cs typeface="Helvetica Neue"/>
               </a:rPr>
-              <a:t>LIVE DEMO</a:t>
-            </a:r>
-          </a:p>
-        </p:txBody>
-      </p:sp>
-      <p:sp>
-        <p:nvSpPr>
-          <p:cNvPr id="5" name="">
-            <a:extLst xmlns:a="http://schemas.openxmlformats.org/drawingml/2006/main">
-              <a:ext uri="{FF2B5EF4-FFF2-40B4-BE49-F238E27FC236}">
-                <a16:creationId xmlns:a16="http://schemas.microsoft.com/office/drawing/2014/main" id="{87534AD9-E8AE-4F01-A2E8-70C2B5321255}"/>
-              </a:ext>
-            </a:extLst>
-          </p:cNvPr>
-          <p:cNvSpPr>
-            <a:spLocks xmlns:a="http://schemas.openxmlformats.org/drawingml/2006/main" noGrp="1"/>
-          </p:cNvSpPr>
-          <p:nvPr/>
-        </p:nvSpPr>
-        <p:spPr>
-          <a:xfrm xmlns:a="http://schemas.openxmlformats.org/drawingml/2006/main">
-            <a:off x="400050" y="5029200"/>
-            <a:ext cx="5048250" cy="361950"/>
+              <a:t>No silent local fallback, no mixed runtime proof, deterministic output validation.</a:t>
+            </a:r>
+          </a:p>
+        </p:txBody>
+      </p:sp>
+      <p:sp>
+        <p:nvSpPr>
+          <p:cNvPr id="18" name="">
+            <a:extLst xmlns:a="http://schemas.openxmlformats.org/drawingml/2006/main">
+              <a:ext uri="{FF2B5EF4-FFF2-40B4-BE49-F238E27FC236}">
+                <a16:creationId xmlns:a16="http://schemas.microsoft.com/office/drawing/2014/main" id="{D0700C7D-5170-4E1D-9B79-E1F87DCE4D2E}"/>
+              </a:ext>
+            </a:extLst>
+          </p:cNvPr>
+          <p:cNvSpPr>
+            <a:spLocks xmlns:a="http://schemas.openxmlformats.org/drawingml/2006/main" noGrp="1"/>
+          </p:cNvSpPr>
+          <p:nvPr/>
+        </p:nvSpPr>
+        <p:spPr>
+          <a:xfrm xmlns:a="http://schemas.openxmlformats.org/drawingml/2006/main">
+            <a:off x="9505950" y="1781175"/>
+            <a:ext cx="9525" cy="3562350"/>
+          </a:xfrm>
+          <a:prstGeom xmlns:a="http://schemas.openxmlformats.org/drawingml/2006/main" prst="rect">
+            <a:avLst/>
+          </a:prstGeom>
+          <a:solidFill xmlns:a="http://schemas.openxmlformats.org/drawingml/2006/main">
+            <a:srgbClr val="B8BCC4"/>
+          </a:solidFill>
+          <a:ln xmlns:a="http://schemas.openxmlformats.org/drawingml/2006/main" w="0">
+            <a:solidFill>
+              <a:srgbClr val="B8BCC4"/>
+            </a:solidFill>
+            <a:prstDash val="solid"/>
+          </a:ln>
+        </p:spPr>
+      </p:sp>
+      <p:sp>
+        <p:nvSpPr>
+          <p:cNvPr id="19" name="">
+            <a:extLst xmlns:a="http://schemas.openxmlformats.org/drawingml/2006/main">
+              <a:ext uri="{FF2B5EF4-FFF2-40B4-BE49-F238E27FC236}">
+                <a16:creationId xmlns:a16="http://schemas.microsoft.com/office/drawing/2014/main" id="{8571E64C-D4D0-43CA-8869-28D96C0C9FFB}"/>
+              </a:ext>
+            </a:extLst>
+          </p:cNvPr>
+          <p:cNvSpPr>
+            <a:spLocks xmlns:a="http://schemas.openxmlformats.org/drawingml/2006/main" noGrp="1"/>
+          </p:cNvSpPr>
+          <p:nvPr/>
+        </p:nvSpPr>
+        <p:spPr>
+          <a:xfrm xmlns:a="http://schemas.openxmlformats.org/drawingml/2006/main">
+            <a:off x="9696450" y="1762125"/>
+            <a:ext cx="1714500" cy="400050"/>
           </a:xfrm>
           <a:prstGeom xmlns:a="http://schemas.openxmlformats.org/drawingml/2006/main" prst="rect">
             <a:avLst/>
@@ -8682,7 +10091,65 @@
           <a:lstStyle xmlns:a="http://schemas.openxmlformats.org/drawingml/2006/main"/>
           <a:p xmlns:a="http://schemas.openxmlformats.org/drawingml/2006/main">
             <a:pPr algn="l">
-              <a:defRPr sz="1650" b="1">
+              <a:buNone/>
+              <a:defRPr sz="1425" b="1">
+                <a:solidFill>
+                  <a:srgbClr val="3D8DFF"/>
+                </a:solidFill>
+                <a:latin typeface="Helvetica Neue"/>
+                <a:ea typeface="Helvetica Neue"/>
+                <a:cs typeface="Helvetica Neue"/>
+              </a:defRPr>
+            </a:pPr>
+            <a:r>
+              <a:rPr sz="1425" b="1">
+                <a:solidFill>
+                  <a:srgbClr val="3D8DFF"/>
+                </a:solidFill>
+                <a:latin typeface="Helvetica Neue"/>
+                <a:ea typeface="Helvetica Neue"/>
+                <a:cs typeface="Helvetica Neue"/>
+              </a:rPr>
+              <a:t>05</a:t>
+            </a:r>
+          </a:p>
+        </p:txBody>
+      </p:sp>
+      <p:sp>
+        <p:nvSpPr>
+          <p:cNvPr id="20" name="">
+            <a:extLst xmlns:a="http://schemas.openxmlformats.org/drawingml/2006/main">
+              <a:ext uri="{FF2B5EF4-FFF2-40B4-BE49-F238E27FC236}">
+                <a16:creationId xmlns:a16="http://schemas.microsoft.com/office/drawing/2014/main" id="{DD2DC681-3AAF-4A00-93CF-8AFE676820DF}"/>
+              </a:ext>
+            </a:extLst>
+          </p:cNvPr>
+          <p:cNvSpPr>
+            <a:spLocks xmlns:a="http://schemas.openxmlformats.org/drawingml/2006/main" noGrp="1"/>
+          </p:cNvSpPr>
+          <p:nvPr/>
+        </p:nvSpPr>
+        <p:spPr>
+          <a:xfrm xmlns:a="http://schemas.openxmlformats.org/drawingml/2006/main">
+            <a:off x="9696450" y="2343150"/>
+            <a:ext cx="1952625" cy="685800"/>
+          </a:xfrm>
+          <a:prstGeom xmlns:a="http://schemas.openxmlformats.org/drawingml/2006/main" prst="rect">
+            <a:avLst/>
+          </a:prstGeom>
+          <a:noFill xmlns:a="http://schemas.openxmlformats.org/drawingml/2006/main"/>
+          <a:ln xmlns:a="http://schemas.openxmlformats.org/drawingml/2006/main" w="0">
+            <a:noFill/>
+            <a:prstDash val="solid"/>
+          </a:ln>
+        </p:spPr>
+        <p:txBody>
+          <a:bodyPr xmlns:a="http://schemas.openxmlformats.org/drawingml/2006/main" anchor="t"/>
+          <a:lstStyle xmlns:a="http://schemas.openxmlformats.org/drawingml/2006/main"/>
+          <a:p xmlns:a="http://schemas.openxmlformats.org/drawingml/2006/main">
+            <a:pPr algn="l">
+              <a:buNone/>
+              <a:defRPr sz="1950" b="1">
                 <a:solidFill>
                   <a:srgbClr val="000000"/>
                 </a:solidFill>
@@ -8692,7 +10159,7 @@
               </a:defRPr>
             </a:pPr>
             <a:r>
-              <a:rPr sz="1650" b="1">
+              <a:rPr sz="1950" b="1">
                 <a:solidFill>
                   <a:srgbClr val="000000"/>
                 </a:solidFill>
@@ -8700,29 +10167,29 @@
                 <a:ea typeface="Helvetica Neue"/>
                 <a:cs typeface="Helvetica Neue"/>
               </a:rPr>
-              <a:t>rc-5ec89b08f896792e.radeon.firstdg.ai</a:t>
-            </a:r>
-          </a:p>
-        </p:txBody>
-      </p:sp>
-      <p:sp>
-        <p:nvSpPr>
-          <p:cNvPr id="6" name="">
-            <a:extLst xmlns:a="http://schemas.openxmlformats.org/drawingml/2006/main">
-              <a:ext uri="{FF2B5EF4-FFF2-40B4-BE49-F238E27FC236}">
-                <a16:creationId xmlns:a16="http://schemas.microsoft.com/office/drawing/2014/main" id="{0C2F1CC4-B5EB-4D1C-B04F-68391AE6D6E2}"/>
-              </a:ext>
-            </a:extLst>
-          </p:cNvPr>
-          <p:cNvSpPr>
-            <a:spLocks xmlns:a="http://schemas.openxmlformats.org/drawingml/2006/main" noGrp="1"/>
-          </p:cNvSpPr>
-          <p:nvPr/>
-        </p:nvSpPr>
-        <p:spPr>
-          <a:xfrm xmlns:a="http://schemas.openxmlformats.org/drawingml/2006/main">
-            <a:off x="5810250" y="4686300"/>
-            <a:ext cx="2190750" cy="266700"/>
+              <a:t>Synthetic only</a:t>
+            </a:r>
+          </a:p>
+        </p:txBody>
+      </p:sp>
+      <p:sp>
+        <p:nvSpPr>
+          <p:cNvPr id="21" name="">
+            <a:extLst xmlns:a="http://schemas.openxmlformats.org/drawingml/2006/main">
+              <a:ext uri="{FF2B5EF4-FFF2-40B4-BE49-F238E27FC236}">
+                <a16:creationId xmlns:a16="http://schemas.microsoft.com/office/drawing/2014/main" id="{46D86350-245C-4D00-B8A3-D40A1ED3AF4F}"/>
+              </a:ext>
+            </a:extLst>
+          </p:cNvPr>
+          <p:cNvSpPr>
+            <a:spLocks xmlns:a="http://schemas.openxmlformats.org/drawingml/2006/main" noGrp="1"/>
+          </p:cNvSpPr>
+          <p:nvPr/>
+        </p:nvSpPr>
+        <p:spPr>
+          <a:xfrm xmlns:a="http://schemas.openxmlformats.org/drawingml/2006/main">
+            <a:off x="9696450" y="3257550"/>
+            <a:ext cx="1924050" cy="1619250"/>
           </a:xfrm>
           <a:prstGeom xmlns:a="http://schemas.openxmlformats.org/drawingml/2006/main" prst="rect">
             <a:avLst/>
@@ -8738,7 +10205,8 @@
           <a:lstStyle xmlns:a="http://schemas.openxmlformats.org/drawingml/2006/main"/>
           <a:p xmlns:a="http://schemas.openxmlformats.org/drawingml/2006/main">
             <a:pPr algn="l">
-              <a:defRPr sz="1350" b="1">
+              <a:buNone/>
+              <a:defRPr sz="1350" b="0">
                 <a:solidFill>
                   <a:srgbClr val="5F6368"/>
                 </a:solidFill>
@@ -8748,7 +10216,7 @@
               </a:defRPr>
             </a:pPr>
             <a:r>
-              <a:rPr sz="1350" b="1">
+              <a:rPr sz="1350" b="0">
                 <a:solidFill>
                   <a:srgbClr val="5F6368"/>
                 </a:solidFill>
@@ -8756,29 +10224,64 @@
                 <a:ea typeface="Helvetica Neue"/>
                 <a:cs typeface="Helvetica Neue"/>
               </a:rPr>
-              <a:t>IMMUTABLE SOURCE</a:t>
-            </a:r>
-          </a:p>
-        </p:txBody>
-      </p:sp>
-      <p:sp>
-        <p:nvSpPr>
-          <p:cNvPr id="7" name="">
-            <a:extLst xmlns:a="http://schemas.openxmlformats.org/drawingml/2006/main">
-              <a:ext uri="{FF2B5EF4-FFF2-40B4-BE49-F238E27FC236}">
-                <a16:creationId xmlns:a16="http://schemas.microsoft.com/office/drawing/2014/main" id="{868E72D7-2616-4BDC-A191-8E67DEAD2797}"/>
-              </a:ext>
-            </a:extLst>
-          </p:cNvPr>
-          <p:cNvSpPr>
-            <a:spLocks xmlns:a="http://schemas.openxmlformats.org/drawingml/2006/main" noGrp="1"/>
-          </p:cNvSpPr>
-          <p:nvPr/>
-        </p:nvSpPr>
-        <p:spPr>
-          <a:xfrm xmlns:a="http://schemas.openxmlformats.org/drawingml/2006/main">
-            <a:off x="5810250" y="5029200"/>
-            <a:ext cx="5619750" cy="361950"/>
+              <a:t>API key stays private; real guest data and private state never leave.</a:t>
+            </a:r>
+          </a:p>
+        </p:txBody>
+      </p:sp>
+      <p:sp>
+        <p:nvSpPr>
+          <p:cNvPr id="22" name="">
+            <a:extLst xmlns:a="http://schemas.openxmlformats.org/drawingml/2006/main">
+              <a:ext uri="{FF2B5EF4-FFF2-40B4-BE49-F238E27FC236}">
+                <a16:creationId xmlns:a16="http://schemas.microsoft.com/office/drawing/2014/main" id="{01D7B705-68A8-402E-A833-2F3D61017A3A}"/>
+              </a:ext>
+            </a:extLst>
+          </p:cNvPr>
+          <p:cNvSpPr>
+            <a:spLocks xmlns:a="http://schemas.openxmlformats.org/drawingml/2006/main" noGrp="1"/>
+          </p:cNvSpPr>
+          <p:nvPr/>
+        </p:nvSpPr>
+        <p:spPr>
+          <a:xfrm xmlns:a="http://schemas.openxmlformats.org/drawingml/2006/main">
+            <a:off x="400050" y="5562600"/>
+            <a:ext cx="11401425" cy="514350"/>
+          </a:xfrm>
+          <a:prstGeom xmlns:a="http://schemas.openxmlformats.org/drawingml/2006/main" prst="roundRect">
+            <a:avLst>
+              <a:gd name="adj" fmla="val 22222"/>
+            </a:avLst>
+          </a:prstGeom>
+          <a:solidFill xmlns:a="http://schemas.openxmlformats.org/drawingml/2006/main">
+            <a:srgbClr val="EAF5FB"/>
+          </a:solidFill>
+          <a:ln xmlns:a="http://schemas.openxmlformats.org/drawingml/2006/main" w="9525">
+            <a:solidFill>
+              <a:srgbClr val="EAF5FB"/>
+            </a:solidFill>
+            <a:prstDash val="solid"/>
+          </a:ln>
+        </p:spPr>
+      </p:sp>
+      <p:sp>
+        <p:nvSpPr>
+          <p:cNvPr id="23" name="">
+            <a:extLst xmlns:a="http://schemas.openxmlformats.org/drawingml/2006/main">
+              <a:ext uri="{FF2B5EF4-FFF2-40B4-BE49-F238E27FC236}">
+                <a16:creationId xmlns:a16="http://schemas.microsoft.com/office/drawing/2014/main" id="{0E3631B2-27B8-4795-AF3B-328252C7559B}"/>
+              </a:ext>
+            </a:extLst>
+          </p:cNvPr>
+          <p:cNvSpPr>
+            <a:spLocks xmlns:a="http://schemas.openxmlformats.org/drawingml/2006/main" noGrp="1"/>
+          </p:cNvSpPr>
+          <p:nvPr/>
+        </p:nvSpPr>
+        <p:spPr>
+          <a:xfrm xmlns:a="http://schemas.openxmlformats.org/drawingml/2006/main">
+            <a:off x="619125" y="5695950"/>
+            <a:ext cx="10953750" cy="266700"/>
           </a:xfrm>
           <a:prstGeom xmlns:a="http://schemas.openxmlformats.org/drawingml/2006/main" prst="rect">
             <a:avLst/>
@@ -8793,8 +10296,9 @@
           <a:bodyPr xmlns:a="http://schemas.openxmlformats.org/drawingml/2006/main" anchor="t"/>
           <a:lstStyle xmlns:a="http://schemas.openxmlformats.org/drawingml/2006/main"/>
           <a:p xmlns:a="http://schemas.openxmlformats.org/drawingml/2006/main">
-            <a:pPr algn="l">
-              <a:defRPr sz="1650" b="1">
+            <a:pPr algn="ctr">
+              <a:buNone/>
+              <a:defRPr sz="1500" b="1">
                 <a:solidFill>
                   <a:srgbClr val="000000"/>
                 </a:solidFill>
@@ -8804,7 +10308,7 @@
               </a:defRPr>
             </a:pPr>
             <a:r>
-              <a:rPr sz="1650" b="1">
+              <a:rPr sz="1500" b="1">
                 <a:solidFill>
                   <a:srgbClr val="000000"/>
                 </a:solidFill>
@@ -8812,63 +10316,7 @@
                 <a:ea typeface="Helvetica Neue"/>
                 <a:cs typeface="Helvetica Neue"/>
               </a:rPr>
-              <a:t>C2 f7ba681 · accepted report 7f85a614</a:t>
-            </a:r>
-          </a:p>
-        </p:txBody>
-      </p:sp>
-      <p:sp>
-        <p:nvSpPr>
-          <p:cNvPr id="8" name="">
-            <a:extLst xmlns:a="http://schemas.openxmlformats.org/drawingml/2006/main">
-              <a:ext uri="{FF2B5EF4-FFF2-40B4-BE49-F238E27FC236}">
-                <a16:creationId xmlns:a16="http://schemas.microsoft.com/office/drawing/2014/main" id="{57741A7E-C6FC-4515-907D-D46F755CBE51}"/>
-              </a:ext>
-            </a:extLst>
-          </p:cNvPr>
-          <p:cNvSpPr>
-            <a:spLocks xmlns:a="http://schemas.openxmlformats.org/drawingml/2006/main" noGrp="1"/>
-          </p:cNvSpPr>
-          <p:nvPr/>
-        </p:nvSpPr>
-        <p:spPr>
-          <a:xfrm xmlns:a="http://schemas.openxmlformats.org/drawingml/2006/main">
-            <a:off x="400050" y="5848350"/>
-            <a:ext cx="11049000" cy="342900"/>
-          </a:xfrm>
-          <a:prstGeom xmlns:a="http://schemas.openxmlformats.org/drawingml/2006/main" prst="rect">
-            <a:avLst/>
-          </a:prstGeom>
-          <a:noFill xmlns:a="http://schemas.openxmlformats.org/drawingml/2006/main"/>
-          <a:ln xmlns:a="http://schemas.openxmlformats.org/drawingml/2006/main" w="0">
-            <a:noFill/>
-            <a:prstDash val="solid"/>
-          </a:ln>
-        </p:spPr>
-        <p:txBody>
-          <a:bodyPr xmlns:a="http://schemas.openxmlformats.org/drawingml/2006/main" anchor="t"/>
-          <a:lstStyle xmlns:a="http://schemas.openxmlformats.org/drawingml/2006/main"/>
-          <a:p xmlns:a="http://schemas.openxmlformats.org/drawingml/2006/main">
-            <a:pPr algn="l">
-              <a:defRPr sz="1575" b="0">
-                <a:solidFill>
-                  <a:srgbClr val="5F6368"/>
-                </a:solidFill>
-                <a:latin typeface="Helvetica Neue"/>
-                <a:ea typeface="Helvetica Neue"/>
-                <a:cs typeface="Helvetica Neue"/>
-              </a:defRPr>
-            </a:pPr>
-            <a:r>
-              <a:rPr sz="1575" b="0">
-                <a:solidFill>
-                  <a:srgbClr val="5F6368"/>
-                </a:solidFill>
-                <a:latin typeface="Helvetica Neue"/>
-                <a:ea typeface="Helvetica Neue"/>
-                <a:cs typeface="Helvetica Neue"/>
-              </a:rPr>
-              <a:t>Local inference · reversible writes · owner-scoped memory · grounded answers · hash-bound Radeon evidence</a:t>
+              <a:t>Optional bonus path; the base-100 local Radeon deployment remains independent.</a:t>
             </a:r>
           </a:p>
         </p:txBody>
@@ -8876,7 +10324,7 @@
     </p:spTree>
     <p:extLst>
       <p:ext uri="{BB962C8B-B14F-4D97-AF65-F5344CB8AC3E}">
-        <p14:creationId xmlns:p14="http://schemas.microsoft.com/office/powerpoint/2010/main" val="755100413"/>
+        <p14:creationId xmlns:p14="http://schemas.microsoft.com/office/powerpoint/2010/main" val="1908043575"/>
       </p:ext>
     </p:extLst>
   </p:cSld>

</xml_diff>